<commit_message>
docs: finalize release artifacts
</commit_message>
<xml_diff>
--- a/deliverables/祝宸旭-操作系统课程设计答辩.pptx
+++ b/deliverables/祝宸旭-操作系统课程设计答辩.pptx
@@ -2,26 +2,26 @@
 <file path=ppt/presentation.xml><?xml version="1.0" encoding="utf-8"?>
 <p:presentation xmlns:p="http://schemas.openxmlformats.org/presentationml/2006/main">
   <p:sldMasterIdLst>
-    <p:sldMasterId xmlns:r="http://schemas.openxmlformats.org/officeDocument/2006/relationships" id="2147483648" r:id="R647c9d0cacf64803"/>
+    <p:sldMasterId xmlns:r="http://schemas.openxmlformats.org/officeDocument/2006/relationships" id="2147483648" r:id="R050f89a551a347b4"/>
   </p:sldMasterIdLst>
   <p:notesMasterIdLst>
-    <p:notesMasterId xmlns:r="http://schemas.openxmlformats.org/officeDocument/2006/relationships" r:id="Rd1147e36a83e446d"/>
+    <p:notesMasterId xmlns:r="http://schemas.openxmlformats.org/officeDocument/2006/relationships" r:id="R98916e4ba34044f0"/>
   </p:notesMasterIdLst>
   <p:sldIdLst>
-    <p:sldId xmlns:r="http://schemas.openxmlformats.org/officeDocument/2006/relationships" id="256" r:id="R3062d67236fd4efa"/>
-    <p:sldId xmlns:r="http://schemas.openxmlformats.org/officeDocument/2006/relationships" id="257" r:id="R22707c2296bf47cf"/>
-    <p:sldId xmlns:r="http://schemas.openxmlformats.org/officeDocument/2006/relationships" id="258" r:id="R9f35b04820814e99"/>
-    <p:sldId xmlns:r="http://schemas.openxmlformats.org/officeDocument/2006/relationships" id="259" r:id="R1f1863fcef7f4cda"/>
-    <p:sldId xmlns:r="http://schemas.openxmlformats.org/officeDocument/2006/relationships" id="260" r:id="R6a9dafd8bfe24989"/>
-    <p:sldId xmlns:r="http://schemas.openxmlformats.org/officeDocument/2006/relationships" id="261" r:id="R0269f3711e6846d5"/>
-    <p:sldId xmlns:r="http://schemas.openxmlformats.org/officeDocument/2006/relationships" id="262" r:id="Ra48a5731b6b34985"/>
-    <p:sldId xmlns:r="http://schemas.openxmlformats.org/officeDocument/2006/relationships" id="263" r:id="R83768398e41044fa"/>
-    <p:sldId xmlns:r="http://schemas.openxmlformats.org/officeDocument/2006/relationships" id="264" r:id="Rc288bcf6767246ca"/>
-    <p:sldId xmlns:r="http://schemas.openxmlformats.org/officeDocument/2006/relationships" id="265" r:id="Rde623362d0674972"/>
-    <p:sldId xmlns:r="http://schemas.openxmlformats.org/officeDocument/2006/relationships" id="266" r:id="Rf0e1795bc091477d"/>
-    <p:sldId xmlns:r="http://schemas.openxmlformats.org/officeDocument/2006/relationships" id="267" r:id="Rbcab6828bb7b4098"/>
-    <p:sldId xmlns:r="http://schemas.openxmlformats.org/officeDocument/2006/relationships" id="268" r:id="Ra684c21928a64816"/>
-    <p:sldId xmlns:r="http://schemas.openxmlformats.org/officeDocument/2006/relationships" id="269" r:id="R0219ea3644a24bc6"/>
+    <p:sldId xmlns:r="http://schemas.openxmlformats.org/officeDocument/2006/relationships" id="256" r:id="R70474e403e2f44c3"/>
+    <p:sldId xmlns:r="http://schemas.openxmlformats.org/officeDocument/2006/relationships" id="257" r:id="R778a1b488018484f"/>
+    <p:sldId xmlns:r="http://schemas.openxmlformats.org/officeDocument/2006/relationships" id="258" r:id="R8a7bdf3612ca448c"/>
+    <p:sldId xmlns:r="http://schemas.openxmlformats.org/officeDocument/2006/relationships" id="259" r:id="R1f49be82dfb94ee2"/>
+    <p:sldId xmlns:r="http://schemas.openxmlformats.org/officeDocument/2006/relationships" id="260" r:id="R43e648da68dc478f"/>
+    <p:sldId xmlns:r="http://schemas.openxmlformats.org/officeDocument/2006/relationships" id="261" r:id="Rb529ef69347d4fe8"/>
+    <p:sldId xmlns:r="http://schemas.openxmlformats.org/officeDocument/2006/relationships" id="262" r:id="R58e8d04099284b7f"/>
+    <p:sldId xmlns:r="http://schemas.openxmlformats.org/officeDocument/2006/relationships" id="263" r:id="Rc9f6ac3103f444c3"/>
+    <p:sldId xmlns:r="http://schemas.openxmlformats.org/officeDocument/2006/relationships" id="264" r:id="Re5985f8b5269456a"/>
+    <p:sldId xmlns:r="http://schemas.openxmlformats.org/officeDocument/2006/relationships" id="265" r:id="R5a841a9f12c44302"/>
+    <p:sldId xmlns:r="http://schemas.openxmlformats.org/officeDocument/2006/relationships" id="266" r:id="R4b673e7bcc8140bc"/>
+    <p:sldId xmlns:r="http://schemas.openxmlformats.org/officeDocument/2006/relationships" id="267" r:id="Rb0fd687b560c49ed"/>
+    <p:sldId xmlns:r="http://schemas.openxmlformats.org/officeDocument/2006/relationships" id="268" r:id="Rb813abc26fd14fe0"/>
+    <p:sldId xmlns:r="http://schemas.openxmlformats.org/officeDocument/2006/relationships" id="269" r:id="R05992ec6884b48bd"/>
   </p:sldIdLst>
   <p:sldSz cx="12192000" cy="6858000"/>
   <p:notesSz cx="6858000" cy="9144000"/>
@@ -645,7 +645,7 @@
           </a:p>
           <a:p xmlns:a="http://schemas.openxmlformats.org/drawingml/2006/main">
             <a:r>
-              <a:t>- Screenshot intentionally pending real user capture</a:t>
+              <a:t>- screenshots/mmaptest-success.png (real terminal capture)</a:t>
             </a:r>
           </a:p>
         </p:txBody>
@@ -811,6 +811,11 @@
           <a:p xmlns:a="http://schemas.openxmlformats.org/drawingml/2006/main">
             <a:r>
               <a:t>- results/util/grade.txt ... results/mmap/grade.txt</a:t>
+            </a:r>
+          </a:p>
+          <a:p xmlns:a="http://schemas.openxmlformats.org/drawingml/2006/main">
+            <a:r>
+              <a:t>- screenshots/grade-846.png (real terminal capture)</a:t>
             </a:r>
           </a:p>
           <a:p xmlns:a="http://schemas.openxmlformats.org/drawingml/2006/main">
@@ -1673,7 +1678,7 @@
   </p:cSld>
   <p:clrMap bg1="lt1" tx1="dk1" bg2="lt2" tx2="dk2" accent1="accent1" accent2="accent2" accent3="accent3" accent4="accent4" accent5="accent5" accent6="accent6" hlink="hlink" folHlink="folHlink"/>
   <p:sldLayoutIdLst>
-    <p:sldLayoutId xmlns:r="http://schemas.openxmlformats.org/officeDocument/2006/relationships" id="2147483649" r:id="Rb5388bcf2dd14c47"/>
+    <p:sldLayoutId xmlns:r="http://schemas.openxmlformats.org/officeDocument/2006/relationships" id="2147483649" r:id="R6079befbe1b5403f"/>
   </p:sldLayoutIdLst>
   <p:txStyles>
     <p:titleStyle>
@@ -2252,6 +2257,7 @@
           <a:lstStyle xmlns:a="http://schemas.openxmlformats.org/drawingml/2006/main"/>
           <a:p xmlns:a="http://schemas.openxmlformats.org/drawingml/2006/main">
             <a:pPr algn="l">
+              <a:buNone/>
               <a:defRPr sz="1350" b="1">
                 <a:solidFill>
                   <a:srgbClr val="1F4E79"/>
@@ -2302,6 +2308,7 @@
           <a:lstStyle xmlns:a="http://schemas.openxmlformats.org/drawingml/2006/main"/>
           <a:p xmlns:a="http://schemas.openxmlformats.org/drawingml/2006/main">
             <a:pPr algn="l">
+              <a:buNone/>
               <a:defRPr sz="4050" b="1">
                 <a:solidFill>
                   <a:srgbClr val="111111"/>
@@ -2319,6 +2326,7 @@
           </a:p>
           <a:p xmlns:a="http://schemas.openxmlformats.org/drawingml/2006/main">
             <a:pPr algn="l">
+              <a:buNone/>
               <a:defRPr sz="4050" b="1">
                 <a:solidFill>
                   <a:srgbClr val="111111"/>
@@ -2369,6 +2377,7 @@
           <a:lstStyle xmlns:a="http://schemas.openxmlformats.org/drawingml/2006/main"/>
           <a:p xmlns:a="http://schemas.openxmlformats.org/drawingml/2006/main">
             <a:pPr algn="l">
+              <a:buNone/>
               <a:defRPr sz="1950" b="1">
                 <a:solidFill>
                   <a:srgbClr val="1F4E79"/>
@@ -2419,6 +2428,7 @@
           <a:lstStyle xmlns:a="http://schemas.openxmlformats.org/drawingml/2006/main"/>
           <a:p xmlns:a="http://schemas.openxmlformats.org/drawingml/2006/main">
             <a:pPr algn="l">
+              <a:buNone/>
               <a:defRPr sz="1575" b="0">
                 <a:solidFill>
                   <a:srgbClr val="5F6368"/>
@@ -2436,6 +2446,7 @@
           </a:p>
           <a:p xmlns:a="http://schemas.openxmlformats.org/drawingml/2006/main">
             <a:pPr algn="l">
+              <a:buNone/>
               <a:defRPr sz="1575" b="0">
                 <a:solidFill>
                   <a:srgbClr val="5F6368"/>
@@ -2453,6 +2464,7 @@
           </a:p>
           <a:p xmlns:a="http://schemas.openxmlformats.org/drawingml/2006/main">
             <a:pPr algn="l">
+              <a:buNone/>
               <a:defRPr sz="1575" b="0">
                 <a:solidFill>
                   <a:srgbClr val="5F6368"/>
@@ -2536,6 +2548,7 @@
           <a:lstStyle xmlns:a="http://schemas.openxmlformats.org/drawingml/2006/main"/>
           <a:p xmlns:a="http://schemas.openxmlformats.org/drawingml/2006/main">
             <a:pPr algn="ctr">
+              <a:buNone/>
               <a:defRPr sz="2100" b="1">
                 <a:solidFill>
                   <a:srgbClr val="1F4E79"/>
@@ -2553,6 +2566,7 @@
           </a:p>
           <a:p xmlns:a="http://schemas.openxmlformats.org/drawingml/2006/main">
             <a:pPr algn="ctr">
+              <a:buNone/>
               <a:defRPr sz="2100" b="1">
                 <a:solidFill>
                   <a:srgbClr val="1F4E79"/>
@@ -2625,6 +2639,7 @@
           <a:lstStyle xmlns:a="http://schemas.openxmlformats.org/drawingml/2006/main"/>
           <a:p xmlns:a="http://schemas.openxmlformats.org/drawingml/2006/main">
             <a:pPr algn="l">
+              <a:buNone/>
               <a:defRPr sz="1050" b="1">
                 <a:solidFill>
                   <a:srgbClr val="1F4E79"/>
@@ -2675,6 +2690,7 @@
           <a:lstStyle xmlns:a="http://schemas.openxmlformats.org/drawingml/2006/main"/>
           <a:p xmlns:a="http://schemas.openxmlformats.org/drawingml/2006/main">
             <a:pPr algn="l">
+              <a:buNone/>
               <a:defRPr sz="2850" b="1">
                 <a:solidFill>
                   <a:srgbClr val="111111"/>
@@ -2725,6 +2741,7 @@
           <a:lstStyle xmlns:a="http://schemas.openxmlformats.org/drawingml/2006/main"/>
           <a:p xmlns:a="http://schemas.openxmlformats.org/drawingml/2006/main">
             <a:pPr algn="r">
+              <a:buNone/>
               <a:defRPr sz="1050" b="0">
                 <a:solidFill>
                   <a:srgbClr val="5F6368"/>
@@ -2812,6 +2829,7 @@
           <a:lstStyle xmlns:a="http://schemas.openxmlformats.org/drawingml/2006/main"/>
           <a:p xmlns:a="http://schemas.openxmlformats.org/drawingml/2006/main">
             <a:pPr algn="ctr">
+              <a:buNone/>
               <a:defRPr sz="1350" b="1">
                 <a:solidFill>
                   <a:srgbClr val="111111"/>
@@ -2829,6 +2847,7 @@
           </a:p>
           <a:p xmlns:a="http://schemas.openxmlformats.org/drawingml/2006/main">
             <a:pPr algn="ctr">
+              <a:buNone/>
               <a:defRPr sz="1350" b="1">
                 <a:solidFill>
                   <a:srgbClr val="111111"/>
@@ -2846,6 +2865,7 @@
           </a:p>
           <a:p xmlns:a="http://schemas.openxmlformats.org/drawingml/2006/main">
             <a:pPr algn="ctr">
+              <a:buNone/>
               <a:defRPr sz="1350" b="1">
                 <a:solidFill>
                   <a:srgbClr val="111111"/>
@@ -2902,6 +2922,7 @@
           <a:lstStyle xmlns:a="http://schemas.openxmlformats.org/drawingml/2006/main"/>
           <a:p xmlns:a="http://schemas.openxmlformats.org/drawingml/2006/main">
             <a:pPr algn="ctr">
+              <a:buNone/>
               <a:defRPr sz="1350" b="1">
                 <a:solidFill>
                   <a:srgbClr val="111111"/>
@@ -2919,6 +2940,7 @@
           </a:p>
           <a:p xmlns:a="http://schemas.openxmlformats.org/drawingml/2006/main">
             <a:pPr algn="ctr">
+              <a:buNone/>
               <a:defRPr sz="1350" b="1">
                 <a:solidFill>
                   <a:srgbClr val="111111"/>
@@ -2936,6 +2958,7 @@
           </a:p>
           <a:p xmlns:a="http://schemas.openxmlformats.org/drawingml/2006/main">
             <a:pPr algn="ctr">
+              <a:buNone/>
               <a:defRPr sz="1350" b="1">
                 <a:solidFill>
                   <a:srgbClr val="111111"/>
@@ -2953,6 +2976,7 @@
           </a:p>
           <a:p xmlns:a="http://schemas.openxmlformats.org/drawingml/2006/main">
             <a:pPr algn="ctr">
+              <a:buNone/>
               <a:defRPr sz="1350" b="1">
                 <a:solidFill>
                   <a:srgbClr val="111111"/>
@@ -3009,6 +3033,7 @@
           <a:lstStyle xmlns:a="http://schemas.openxmlformats.org/drawingml/2006/main"/>
           <a:p xmlns:a="http://schemas.openxmlformats.org/drawingml/2006/main">
             <a:pPr algn="ctr">
+              <a:buNone/>
               <a:defRPr sz="1350" b="1">
                 <a:solidFill>
                   <a:srgbClr val="111111"/>
@@ -3026,6 +3051,7 @@
           </a:p>
           <a:p xmlns:a="http://schemas.openxmlformats.org/drawingml/2006/main">
             <a:pPr algn="ctr">
+              <a:buNone/>
               <a:defRPr sz="1350" b="1">
                 <a:solidFill>
                   <a:srgbClr val="111111"/>
@@ -3043,6 +3069,7 @@
           </a:p>
           <a:p xmlns:a="http://schemas.openxmlformats.org/drawingml/2006/main">
             <a:pPr algn="ctr">
+              <a:buNone/>
               <a:defRPr sz="1350" b="1">
                 <a:solidFill>
                   <a:srgbClr val="111111"/>
@@ -3099,6 +3126,7 @@
           <a:lstStyle xmlns:a="http://schemas.openxmlformats.org/drawingml/2006/main"/>
           <a:p xmlns:a="http://schemas.openxmlformats.org/drawingml/2006/main">
             <a:pPr algn="ctr">
+              <a:buNone/>
               <a:defRPr sz="1350" b="1">
                 <a:solidFill>
                   <a:srgbClr val="111111"/>
@@ -3116,6 +3144,7 @@
           </a:p>
           <a:p xmlns:a="http://schemas.openxmlformats.org/drawingml/2006/main">
             <a:pPr algn="ctr">
+              <a:buNone/>
               <a:defRPr sz="1350" b="1">
                 <a:solidFill>
                   <a:srgbClr val="111111"/>
@@ -3133,6 +3162,7 @@
           </a:p>
           <a:p xmlns:a="http://schemas.openxmlformats.org/drawingml/2006/main">
             <a:pPr algn="ctr">
+              <a:buNone/>
               <a:defRPr sz="1350" b="1">
                 <a:solidFill>
                   <a:srgbClr val="111111"/>
@@ -3189,6 +3219,7 @@
           <a:lstStyle xmlns:a="http://schemas.openxmlformats.org/drawingml/2006/main"/>
           <a:p xmlns:a="http://schemas.openxmlformats.org/drawingml/2006/main">
             <a:pPr algn="ctr">
+              <a:buNone/>
               <a:defRPr sz="1350" b="1">
                 <a:solidFill>
                   <a:srgbClr val="111111"/>
@@ -3206,6 +3237,7 @@
           </a:p>
           <a:p xmlns:a="http://schemas.openxmlformats.org/drawingml/2006/main">
             <a:pPr algn="ctr">
+              <a:buNone/>
               <a:defRPr sz="1350" b="1">
                 <a:solidFill>
                   <a:srgbClr val="111111"/>
@@ -3223,6 +3255,7 @@
           </a:p>
           <a:p xmlns:a="http://schemas.openxmlformats.org/drawingml/2006/main">
             <a:pPr algn="ctr">
+              <a:buNone/>
               <a:defRPr sz="1350" b="1">
                 <a:solidFill>
                   <a:srgbClr val="111111"/>
@@ -3279,6 +3312,7 @@
           <a:lstStyle xmlns:a="http://schemas.openxmlformats.org/drawingml/2006/main"/>
           <a:p xmlns:a="http://schemas.openxmlformats.org/drawingml/2006/main">
             <a:pPr algn="ctr">
+              <a:buNone/>
               <a:defRPr sz="1350" b="1">
                 <a:solidFill>
                   <a:srgbClr val="111111"/>
@@ -3296,6 +3330,7 @@
           </a:p>
           <a:p xmlns:a="http://schemas.openxmlformats.org/drawingml/2006/main">
             <a:pPr algn="ctr">
+              <a:buNone/>
               <a:defRPr sz="1350" b="1">
                 <a:solidFill>
                   <a:srgbClr val="111111"/>
@@ -3313,6 +3348,7 @@
           </a:p>
           <a:p xmlns:a="http://schemas.openxmlformats.org/drawingml/2006/main">
             <a:pPr algn="ctr">
+              <a:buNone/>
               <a:defRPr sz="1350" b="1">
                 <a:solidFill>
                   <a:srgbClr val="111111"/>
@@ -3332,7 +3368,7 @@
       </p:sp>
       <p:cxnSp>
         <p:nvCxnSpPr>
-          <p:cNvPr id="30" name=""/>
+          <p:cNvPr id="60" name=""/>
           <p:cNvCxnSpPr>
             <a:stCxn xmlns:a="http://schemas.openxmlformats.org/drawingml/2006/main" id="5" idx="3"/>
             <a:endCxn xmlns:a="http://schemas.openxmlformats.org/drawingml/2006/main" id="6" idx="1"/>
@@ -3358,7 +3394,7 @@
       </p:cxnSp>
       <p:cxnSp>
         <p:nvCxnSpPr>
-          <p:cNvPr id="31" name=""/>
+          <p:cNvPr id="61" name=""/>
           <p:cNvCxnSpPr>
             <a:stCxn xmlns:a="http://schemas.openxmlformats.org/drawingml/2006/main" id="6" idx="3"/>
             <a:endCxn xmlns:a="http://schemas.openxmlformats.org/drawingml/2006/main" id="7" idx="1"/>
@@ -3384,7 +3420,7 @@
       </p:cxnSp>
       <p:cxnSp>
         <p:nvCxnSpPr>
-          <p:cNvPr id="32" name=""/>
+          <p:cNvPr id="62" name=""/>
           <p:cNvCxnSpPr>
             <a:stCxn xmlns:a="http://schemas.openxmlformats.org/drawingml/2006/main" id="7" idx="3"/>
             <a:endCxn xmlns:a="http://schemas.openxmlformats.org/drawingml/2006/main" id="8" idx="1"/>
@@ -3410,7 +3446,7 @@
       </p:cxnSp>
       <p:cxnSp>
         <p:nvCxnSpPr>
-          <p:cNvPr id="33" name=""/>
+          <p:cNvPr id="63" name=""/>
           <p:cNvCxnSpPr>
             <a:stCxn xmlns:a="http://schemas.openxmlformats.org/drawingml/2006/main" id="8" idx="3"/>
             <a:endCxn xmlns:a="http://schemas.openxmlformats.org/drawingml/2006/main" id="9" idx="1"/>
@@ -3436,7 +3472,7 @@
       </p:cxnSp>
       <p:cxnSp>
         <p:nvCxnSpPr>
-          <p:cNvPr id="34" name=""/>
+          <p:cNvPr id="64" name=""/>
           <p:cNvCxnSpPr>
             <a:stCxn xmlns:a="http://schemas.openxmlformats.org/drawingml/2006/main" id="9" idx="3"/>
             <a:endCxn xmlns:a="http://schemas.openxmlformats.org/drawingml/2006/main" id="10" idx="1"/>
@@ -3493,6 +3529,7 @@
           <a:lstStyle xmlns:a="http://schemas.openxmlformats.org/drawingml/2006/main"/>
           <a:p xmlns:a="http://schemas.openxmlformats.org/drawingml/2006/main">
             <a:pPr algn="l">
+              <a:buNone/>
               <a:defRPr sz="1875" b="1">
                 <a:solidFill>
                   <a:srgbClr val="1F4E79"/>
@@ -3543,6 +3580,7 @@
           <a:lstStyle xmlns:a="http://schemas.openxmlformats.org/drawingml/2006/main"/>
           <a:p xmlns:a="http://schemas.openxmlformats.org/drawingml/2006/main">
             <a:pPr algn="l">
+              <a:buNone/>
               <a:defRPr sz="2400" b="1">
                 <a:solidFill>
                   <a:srgbClr val="111111"/>
@@ -3593,6 +3631,7 @@
           <a:lstStyle xmlns:a="http://schemas.openxmlformats.org/drawingml/2006/main"/>
           <a:p xmlns:a="http://schemas.openxmlformats.org/drawingml/2006/main">
             <a:pPr algn="l">
+              <a:buNone/>
               <a:defRPr sz="4500" b="1">
                 <a:solidFill>
                   <a:srgbClr val="1F4E79"/>
@@ -3643,6 +3682,7 @@
           <a:lstStyle xmlns:a="http://schemas.openxmlformats.org/drawingml/2006/main"/>
           <a:p xmlns:a="http://schemas.openxmlformats.org/drawingml/2006/main">
             <a:pPr algn="l">
+              <a:buNone/>
               <a:defRPr sz="1500" b="0">
                 <a:solidFill>
                   <a:srgbClr val="5F6368"/>
@@ -3715,6 +3755,7 @@
           <a:lstStyle xmlns:a="http://schemas.openxmlformats.org/drawingml/2006/main"/>
           <a:p xmlns:a="http://schemas.openxmlformats.org/drawingml/2006/main">
             <a:pPr algn="l">
+              <a:buNone/>
               <a:defRPr sz="1050" b="1">
                 <a:solidFill>
                   <a:srgbClr val="1F4E79"/>
@@ -3765,6 +3806,7 @@
           <a:lstStyle xmlns:a="http://schemas.openxmlformats.org/drawingml/2006/main"/>
           <a:p xmlns:a="http://schemas.openxmlformats.org/drawingml/2006/main">
             <a:pPr algn="l">
+              <a:buNone/>
               <a:defRPr sz="2850" b="1">
                 <a:solidFill>
                   <a:srgbClr val="111111"/>
@@ -3815,6 +3857,7 @@
           <a:lstStyle xmlns:a="http://schemas.openxmlformats.org/drawingml/2006/main"/>
           <a:p xmlns:a="http://schemas.openxmlformats.org/drawingml/2006/main">
             <a:pPr algn="r">
+              <a:buNone/>
               <a:defRPr sz="1050" b="0">
                 <a:solidFill>
                   <a:srgbClr val="5F6368"/>
@@ -3896,6 +3939,7 @@
           <a:lstStyle xmlns:a="http://schemas.openxmlformats.org/drawingml/2006/main"/>
           <a:p xmlns:a="http://schemas.openxmlformats.org/drawingml/2006/main">
             <a:pPr algn="l">
+              <a:buNone/>
               <a:defRPr sz="1875" b="1">
                 <a:solidFill>
                   <a:srgbClr val="1F4E79"/>
@@ -3979,6 +4023,7 @@
           <a:lstStyle xmlns:a="http://schemas.openxmlformats.org/drawingml/2006/main"/>
           <a:p xmlns:a="http://schemas.openxmlformats.org/drawingml/2006/main">
             <a:pPr algn="l">
+              <a:buNone/>
               <a:defRPr sz="1500" b="0">
                 <a:solidFill>
                   <a:srgbClr val="FFFFFF"/>
@@ -3996,6 +4041,7 @@
           </a:p>
           <a:p xmlns:a="http://schemas.openxmlformats.org/drawingml/2006/main">
             <a:pPr algn="l">
+              <a:buNone/>
               <a:defRPr sz="1500" b="0">
                 <a:solidFill>
                   <a:srgbClr val="FFFFFF"/>
@@ -4046,6 +4092,7 @@
           <a:lstStyle xmlns:a="http://schemas.openxmlformats.org/drawingml/2006/main"/>
           <a:p xmlns:a="http://schemas.openxmlformats.org/drawingml/2006/main">
             <a:pPr algn="l">
+              <a:buNone/>
               <a:defRPr sz="1575" b="0">
                 <a:solidFill>
                   <a:srgbClr val="111111"/>
@@ -4058,11 +4105,12 @@
                   <a:srgbClr val="111111"/>
                 </a:solidFill>
               </a:rPr>
-              <a:t>• 预期：mmaptest: all tests succeeded</a:t>
+              <a:t>• 结果：mmaptest: all tests succeeded</a:t>
             </a:r>
           </a:p>
           <a:p xmlns:a="http://schemas.openxmlformats.org/drawingml/2006/main">
             <a:pPr algn="l">
+              <a:buNone/>
               <a:defRPr sz="1575" b="0">
                 <a:solidFill>
                   <a:srgbClr val="111111"/>
@@ -4075,23 +4123,6 @@
                   <a:srgbClr val="111111"/>
                 </a:solidFill>
               </a:rPr>
-              <a:t>• 退出：Ctrl-a x</a:t>
-            </a:r>
-          </a:p>
-          <a:p xmlns:a="http://schemas.openxmlformats.org/drawingml/2006/main">
-            <a:pPr algn="l">
-              <a:defRPr sz="1575" b="0">
-                <a:solidFill>
-                  <a:srgbClr val="111111"/>
-                </a:solidFill>
-              </a:defRPr>
-            </a:pPr>
-            <a:r>
-              <a:rPr sz="1575" b="0">
-                <a:solidFill>
-                  <a:srgbClr val="111111"/>
-                </a:solidFill>
-              </a:rPr>
               <a:t>• 备用：cow demo → cowtest</a:t>
             </a:r>
           </a:p>
@@ -4099,55 +4130,22 @@
       </p:sp>
       <p:sp>
         <p:nvSpPr>
-          <p:cNvPr id="9" name="">
-            <a:extLst xmlns:a="http://schemas.openxmlformats.org/drawingml/2006/main">
-              <a:ext uri="{FF2B5EF4-FFF2-40B4-BE49-F238E27FC236}">
-                <a16:creationId xmlns:a16="http://schemas.microsoft.com/office/drawing/2014/main" id="{E1ECA51A-0D6D-4C6A-A683-9552085F5F85}"/>
-              </a:ext>
-            </a:extLst>
-          </p:cNvPr>
-          <p:cNvSpPr>
-            <a:spLocks xmlns:a="http://schemas.openxmlformats.org/drawingml/2006/main" noGrp="1"/>
-          </p:cNvSpPr>
-          <p:nvPr/>
-        </p:nvSpPr>
-        <p:spPr>
-          <a:xfrm xmlns:a="http://schemas.openxmlformats.org/drawingml/2006/main">
-            <a:off x="6477000" y="1752600"/>
-            <a:ext cx="5029200" cy="3009900"/>
-          </a:xfrm>
-          <a:prstGeom xmlns:a="http://schemas.openxmlformats.org/drawingml/2006/main" prst="rect">
-            <a:avLst/>
-          </a:prstGeom>
-          <a:solidFill xmlns:a="http://schemas.openxmlformats.org/drawingml/2006/main">
-            <a:srgbClr val="F0F2F5"/>
-          </a:solidFill>
-          <a:ln xmlns:a="http://schemas.openxmlformats.org/drawingml/2006/main" w="19050">
-            <a:solidFill>
-              <a:srgbClr val="B8BCC4"/>
-            </a:solidFill>
-            <a:prstDash val="dash"/>
-          </a:ln>
-        </p:spPr>
-      </p:sp>
-      <p:sp>
-        <p:nvSpPr>
-          <p:cNvPr id="10" name="">
-            <a:extLst xmlns:a="http://schemas.openxmlformats.org/drawingml/2006/main">
-              <a:ext uri="{FF2B5EF4-FFF2-40B4-BE49-F238E27FC236}">
-                <a16:creationId xmlns:a16="http://schemas.microsoft.com/office/drawing/2014/main" id="{A2DF76CE-07A1-4B48-AFA3-D28ED415BBB5}"/>
-              </a:ext>
-            </a:extLst>
-          </p:cNvPr>
-          <p:cNvSpPr>
-            <a:spLocks xmlns:a="http://schemas.openxmlformats.org/drawingml/2006/main" noGrp="1"/>
-          </p:cNvSpPr>
-          <p:nvPr/>
-        </p:nvSpPr>
-        <p:spPr>
-          <a:xfrm xmlns:a="http://schemas.openxmlformats.org/drawingml/2006/main">
-            <a:off x="6800850" y="2724150"/>
-            <a:ext cx="4381500" cy="876300"/>
+          <p:cNvPr id="11" name="">
+            <a:extLst xmlns:a="http://schemas.openxmlformats.org/drawingml/2006/main">
+              <a:ext uri="{FF2B5EF4-FFF2-40B4-BE49-F238E27FC236}">
+                <a16:creationId xmlns:a16="http://schemas.microsoft.com/office/drawing/2014/main" id="{8B2C09C5-3C75-4D9D-83C7-B4B40D2485AC}"/>
+              </a:ext>
+            </a:extLst>
+          </p:cNvPr>
+          <p:cNvSpPr>
+            <a:spLocks xmlns:a="http://schemas.openxmlformats.org/drawingml/2006/main" noGrp="1"/>
+          </p:cNvSpPr>
+          <p:nvPr/>
+        </p:nvSpPr>
+        <p:spPr>
+          <a:xfrm xmlns:a="http://schemas.openxmlformats.org/drawingml/2006/main">
+            <a:off x="685800" y="5581650"/>
+            <a:ext cx="10820400" cy="400050"/>
           </a:xfrm>
           <a:prstGeom xmlns:a="http://schemas.openxmlformats.org/drawingml/2006/main" prst="rect">
             <a:avLst/>
@@ -4159,94 +4157,50 @@
           </a:ln>
         </p:spPr>
         <p:txBody>
-          <a:bodyPr xmlns:a="http://schemas.openxmlformats.org/drawingml/2006/main" anchor="ctr"/>
+          <a:bodyPr xmlns:a="http://schemas.openxmlformats.org/drawingml/2006/main" anchor="t"/>
           <a:lstStyle xmlns:a="http://schemas.openxmlformats.org/drawingml/2006/main"/>
           <a:p xmlns:a="http://schemas.openxmlformats.org/drawingml/2006/main">
             <a:pPr algn="ctr">
-              <a:defRPr sz="2100" b="1">
-                <a:solidFill>
-                  <a:srgbClr val="5F6368"/>
-                </a:solidFill>
-              </a:defRPr>
-            </a:pPr>
-            <a:r>
-              <a:rPr sz="2100" b="1">
-                <a:solidFill>
-                  <a:srgbClr val="5F6368"/>
-                </a:solidFill>
-              </a:rPr>
-              <a:t>真实终端截图</a:t>
-            </a:r>
-          </a:p>
-          <a:p xmlns:a="http://schemas.openxmlformats.org/drawingml/2006/main">
-            <a:pPr algn="ctr">
-              <a:defRPr sz="2100" b="1">
-                <a:solidFill>
-                  <a:srgbClr val="5F6368"/>
-                </a:solidFill>
-              </a:defRPr>
-            </a:pPr>
-            <a:r>
-              <a:rPr sz="2100" b="1">
-                <a:solidFill>
-                  <a:srgbClr val="5F6368"/>
-                </a:solidFill>
-              </a:rPr>
-              <a:t>待本人在最终答辩机器采集</a:t>
-            </a:r>
-          </a:p>
-        </p:txBody>
-      </p:sp>
-      <p:sp>
-        <p:nvSpPr>
-          <p:cNvPr id="11" name="">
-            <a:extLst xmlns:a="http://schemas.openxmlformats.org/drawingml/2006/main">
-              <a:ext uri="{FF2B5EF4-FFF2-40B4-BE49-F238E27FC236}">
-                <a16:creationId xmlns:a16="http://schemas.microsoft.com/office/drawing/2014/main" id="{8B2C09C5-3C75-4D9D-83C7-B4B40D2485AC}"/>
-              </a:ext>
-            </a:extLst>
-          </p:cNvPr>
-          <p:cNvSpPr>
-            <a:spLocks xmlns:a="http://schemas.openxmlformats.org/drawingml/2006/main" noGrp="1"/>
-          </p:cNvSpPr>
-          <p:nvPr/>
-        </p:nvSpPr>
-        <p:spPr>
-          <a:xfrm xmlns:a="http://schemas.openxmlformats.org/drawingml/2006/main">
-            <a:off x="685800" y="5581650"/>
-            <a:ext cx="10820400" cy="400050"/>
+              <a:buNone/>
+              <a:defRPr sz="2250" b="1">
+                <a:solidFill>
+                  <a:srgbClr val="1F4E79"/>
+                </a:solidFill>
+              </a:defRPr>
+            </a:pPr>
+            <a:r>
+              <a:rPr sz="2250" b="1">
+                <a:solidFill>
+                  <a:srgbClr val="1F4E79"/>
+                </a:solidFill>
+              </a:rPr>
+              <a:t>10 Labs · 846/846 · COW + mmap</a:t>
+            </a:r>
+          </a:p>
+        </p:txBody>
+      </p:sp>
+      <p:pic>
+        <p:nvPicPr>
+          <p:cNvPr id="23" name=""/>
+          <p:cNvPicPr>
+            <a:picLocks xmlns:a="http://schemas.openxmlformats.org/drawingml/2006/main" noChangeAspect="1"/>
+          </p:cNvPicPr>
+          <p:nvPr/>
+        </p:nvPicPr>
+        <p:blipFill>
+          <a:blip xmlns:r="http://schemas.openxmlformats.org/officeDocument/2006/relationships" xmlns:a="http://schemas.openxmlformats.org/drawingml/2006/main" r:embed="R5cfb3385a4134b6f"/>
+          <a:stretch xmlns:a="http://schemas.openxmlformats.org/drawingml/2006/main"/>
+        </p:blipFill>
+        <p:spPr>
+          <a:xfrm xmlns:a="http://schemas.openxmlformats.org/drawingml/2006/main">
+            <a:off x="7207956" y="1752600"/>
+            <a:ext cx="3567289" cy="3009900"/>
           </a:xfrm>
           <a:prstGeom xmlns:a="http://schemas.openxmlformats.org/drawingml/2006/main" prst="rect">
             <a:avLst/>
           </a:prstGeom>
-          <a:noFill xmlns:a="http://schemas.openxmlformats.org/drawingml/2006/main"/>
-          <a:ln xmlns:a="http://schemas.openxmlformats.org/drawingml/2006/main" w="0">
-            <a:noFill/>
-            <a:prstDash val="solid"/>
-          </a:ln>
-        </p:spPr>
-        <p:txBody>
-          <a:bodyPr xmlns:a="http://schemas.openxmlformats.org/drawingml/2006/main" anchor="t"/>
-          <a:lstStyle xmlns:a="http://schemas.openxmlformats.org/drawingml/2006/main"/>
-          <a:p xmlns:a="http://schemas.openxmlformats.org/drawingml/2006/main">
-            <a:pPr algn="ctr">
-              <a:defRPr sz="2250" b="1">
-                <a:solidFill>
-                  <a:srgbClr val="1F4E79"/>
-                </a:solidFill>
-              </a:defRPr>
-            </a:pPr>
-            <a:r>
-              <a:rPr sz="2250" b="1">
-                <a:solidFill>
-                  <a:srgbClr val="1F4E79"/>
-                </a:solidFill>
-              </a:rPr>
-              <a:t>10 Labs · 846/846 · COW + mmap</a:t>
-            </a:r>
-          </a:p>
-        </p:txBody>
-      </p:sp>
+        </p:spPr>
+      </p:pic>
     </p:spTree>
     <p:extLst>
       <p:ext uri="{BB962C8B-B14F-4D97-AF65-F5344CB8AC3E}">
@@ -4302,6 +4256,7 @@
           <a:lstStyle xmlns:a="http://schemas.openxmlformats.org/drawingml/2006/main"/>
           <a:p xmlns:a="http://schemas.openxmlformats.org/drawingml/2006/main">
             <a:pPr algn="l">
+              <a:buNone/>
               <a:defRPr sz="1050" b="1">
                 <a:solidFill>
                   <a:srgbClr val="5F6368"/>
@@ -4352,6 +4307,7 @@
           <a:lstStyle xmlns:a="http://schemas.openxmlformats.org/drawingml/2006/main"/>
           <a:p xmlns:a="http://schemas.openxmlformats.org/drawingml/2006/main">
             <a:pPr algn="l">
+              <a:buNone/>
               <a:defRPr sz="2850" b="1">
                 <a:solidFill>
                   <a:srgbClr val="111111"/>
@@ -4402,6 +4358,7 @@
           <a:lstStyle xmlns:a="http://schemas.openxmlformats.org/drawingml/2006/main"/>
           <a:p xmlns:a="http://schemas.openxmlformats.org/drawingml/2006/main">
             <a:pPr algn="r">
+              <a:buNone/>
               <a:defRPr sz="1050" b="0">
                 <a:solidFill>
                   <a:srgbClr val="5F6368"/>
@@ -4489,6 +4446,7 @@
           <a:lstStyle xmlns:a="http://schemas.openxmlformats.org/drawingml/2006/main"/>
           <a:p xmlns:a="http://schemas.openxmlformats.org/drawingml/2006/main">
             <a:pPr algn="ctr">
+              <a:buNone/>
               <a:defRPr sz="1350" b="1">
                 <a:solidFill>
                   <a:srgbClr val="111111"/>
@@ -4545,6 +4503,7 @@
           <a:lstStyle xmlns:a="http://schemas.openxmlformats.org/drawingml/2006/main"/>
           <a:p xmlns:a="http://schemas.openxmlformats.org/drawingml/2006/main">
             <a:pPr algn="ctr">
+              <a:buNone/>
               <a:defRPr sz="1350" b="1">
                 <a:solidFill>
                   <a:srgbClr val="111111"/>
@@ -4562,6 +4521,7 @@
           </a:p>
           <a:p xmlns:a="http://schemas.openxmlformats.org/drawingml/2006/main">
             <a:pPr algn="ctr">
+              <a:buNone/>
               <a:defRPr sz="1350" b="1">
                 <a:solidFill>
                   <a:srgbClr val="111111"/>
@@ -4618,6 +4578,7 @@
           <a:lstStyle xmlns:a="http://schemas.openxmlformats.org/drawingml/2006/main"/>
           <a:p xmlns:a="http://schemas.openxmlformats.org/drawingml/2006/main">
             <a:pPr algn="ctr">
+              <a:buNone/>
               <a:defRPr sz="1350" b="1">
                 <a:solidFill>
                   <a:srgbClr val="111111"/>
@@ -4635,6 +4596,7 @@
           </a:p>
           <a:p xmlns:a="http://schemas.openxmlformats.org/drawingml/2006/main">
             <a:pPr algn="ctr">
+              <a:buNone/>
               <a:defRPr sz="1350" b="1">
                 <a:solidFill>
                   <a:srgbClr val="111111"/>
@@ -4691,6 +4653,7 @@
           <a:lstStyle xmlns:a="http://schemas.openxmlformats.org/drawingml/2006/main"/>
           <a:p xmlns:a="http://schemas.openxmlformats.org/drawingml/2006/main">
             <a:pPr algn="ctr">
+              <a:buNone/>
               <a:defRPr sz="1800" b="1">
                 <a:solidFill>
                   <a:srgbClr val="111111"/>
@@ -4708,6 +4671,7 @@
           </a:p>
           <a:p xmlns:a="http://schemas.openxmlformats.org/drawingml/2006/main">
             <a:pPr algn="ctr">
+              <a:buNone/>
               <a:defRPr sz="1800" b="1">
                 <a:solidFill>
                   <a:srgbClr val="111111"/>
@@ -4727,7 +4691,7 @@
       </p:sp>
       <p:cxnSp>
         <p:nvCxnSpPr>
-          <p:cNvPr id="23" name=""/>
+          <p:cNvPr id="47" name=""/>
           <p:cNvCxnSpPr>
             <a:stCxn xmlns:a="http://schemas.openxmlformats.org/drawingml/2006/main" id="5" idx="3"/>
             <a:endCxn xmlns:a="http://schemas.openxmlformats.org/drawingml/2006/main" id="6" idx="1"/>
@@ -4753,7 +4717,7 @@
       </p:cxnSp>
       <p:cxnSp>
         <p:nvCxnSpPr>
-          <p:cNvPr id="24" name=""/>
+          <p:cNvPr id="48" name=""/>
           <p:cNvCxnSpPr>
             <a:stCxn xmlns:a="http://schemas.openxmlformats.org/drawingml/2006/main" id="6" idx="3"/>
             <a:endCxn xmlns:a="http://schemas.openxmlformats.org/drawingml/2006/main" id="8" idx="1"/>
@@ -4779,7 +4743,7 @@
       </p:cxnSp>
       <p:cxnSp>
         <p:nvCxnSpPr>
-          <p:cNvPr id="25" name=""/>
+          <p:cNvPr id="49" name=""/>
           <p:cNvCxnSpPr>
             <a:stCxn xmlns:a="http://schemas.openxmlformats.org/drawingml/2006/main" id="8" idx="1"/>
             <a:endCxn xmlns:a="http://schemas.openxmlformats.org/drawingml/2006/main" id="7" idx="3"/>
@@ -4805,7 +4769,7 @@
       </p:cxnSp>
       <p:cxnSp>
         <p:nvCxnSpPr>
-          <p:cNvPr id="26" name=""/>
+          <p:cNvPr id="50" name=""/>
           <p:cNvCxnSpPr>
             <a:stCxn xmlns:a="http://schemas.openxmlformats.org/drawingml/2006/main" id="7" idx="1"/>
             <a:endCxn xmlns:a="http://schemas.openxmlformats.org/drawingml/2006/main" id="5" idx="3"/>
@@ -4862,6 +4826,7 @@
           <a:lstStyle xmlns:a="http://schemas.openxmlformats.org/drawingml/2006/main"/>
           <a:p xmlns:a="http://schemas.openxmlformats.org/drawingml/2006/main">
             <a:pPr algn="l">
+              <a:buNone/>
               <a:defRPr sz="1350" b="0">
                 <a:solidFill>
                   <a:srgbClr val="111111"/>
@@ -4879,6 +4844,7 @@
           </a:p>
           <a:p xmlns:a="http://schemas.openxmlformats.org/drawingml/2006/main">
             <a:pPr algn="l">
+              <a:buNone/>
               <a:defRPr sz="1350" b="0">
                 <a:solidFill>
                   <a:srgbClr val="111111"/>
@@ -4896,6 +4862,7 @@
           </a:p>
           <a:p xmlns:a="http://schemas.openxmlformats.org/drawingml/2006/main">
             <a:pPr algn="l">
+              <a:buNone/>
               <a:defRPr sz="1350" b="0">
                 <a:solidFill>
                   <a:srgbClr val="111111"/>
@@ -4946,6 +4913,7 @@
           <a:lstStyle xmlns:a="http://schemas.openxmlformats.org/drawingml/2006/main"/>
           <a:p xmlns:a="http://schemas.openxmlformats.org/drawingml/2006/main">
             <a:pPr algn="ctr">
+              <a:buNone/>
               <a:defRPr sz="1500" b="1">
                 <a:solidFill>
                   <a:srgbClr val="1F4E79"/>
@@ -4963,6 +4931,7 @@
           </a:p>
           <a:p xmlns:a="http://schemas.openxmlformats.org/drawingml/2006/main">
             <a:pPr algn="ctr">
+              <a:buNone/>
               <a:defRPr sz="1500" b="1">
                 <a:solidFill>
                   <a:srgbClr val="1F4E79"/>
@@ -5035,6 +5004,7 @@
           <a:lstStyle xmlns:a="http://schemas.openxmlformats.org/drawingml/2006/main"/>
           <a:p xmlns:a="http://schemas.openxmlformats.org/drawingml/2006/main">
             <a:pPr algn="l">
+              <a:buNone/>
               <a:defRPr sz="1050" b="1">
                 <a:solidFill>
                   <a:srgbClr val="5F6368"/>
@@ -5085,6 +5055,7 @@
           <a:lstStyle xmlns:a="http://schemas.openxmlformats.org/drawingml/2006/main"/>
           <a:p xmlns:a="http://schemas.openxmlformats.org/drawingml/2006/main">
             <a:pPr algn="l">
+              <a:buNone/>
               <a:defRPr sz="2850" b="1">
                 <a:solidFill>
                   <a:srgbClr val="111111"/>
@@ -5135,6 +5106,7 @@
           <a:lstStyle xmlns:a="http://schemas.openxmlformats.org/drawingml/2006/main"/>
           <a:p xmlns:a="http://schemas.openxmlformats.org/drawingml/2006/main">
             <a:pPr algn="r">
+              <a:buNone/>
               <a:defRPr sz="1050" b="0">
                 <a:solidFill>
                   <a:srgbClr val="5F6368"/>
@@ -5183,886 +5155,28 @@
           </a:ln>
         </p:spPr>
       </p:sp>
-      <p:graphicFrame>
-        <p:nvGraphicFramePr>
-          <p:cNvPr id="10" name=""/>
-          <p:cNvGraphicFramePr/>
-          <p:nvPr/>
-        </p:nvGraphicFramePr>
-        <p:xfrm>
-          <a:off xmlns:a="http://schemas.openxmlformats.org/drawingml/2006/main" x="1524000" y="1638300"/>
-          <a:ext xmlns:a="http://schemas.openxmlformats.org/drawingml/2006/main" cx="9144000" cy="4229100"/>
-        </p:xfrm>
-        <a:graphic xmlns:a="http://schemas.openxmlformats.org/drawingml/2006/main">
-          <a:graphicData uri="http://schemas.openxmlformats.org/drawingml/2006/table">
-            <a:tbl>
-              <a:tblPr firstRow="1" lastRow="1"/>
-              <a:tblGrid>
-                <a:gridCol w="1619250"/>
-                <a:gridCol w="1619250"/>
-                <a:gridCol w="4095750"/>
-                <a:gridCol w="1619250"/>
-              </a:tblGrid>
-              <a:tr h="352425">
-                <a:tc>
-                  <a:txBody>
-                    <a:bodyPr/>
-                    <a:lstStyle/>
-                    <a:p>
-                      <a:r>
-                        <a:rPr sz="1275" b="1">
-                          <a:solidFill>
-                            <a:srgbClr val="111111"/>
-                          </a:solidFill>
-                        </a:rPr>
-                        <a:t>Lab</a:t>
-                      </a:r>
-                    </a:p>
-                  </a:txBody>
-                  <a:tcPr marL="91440" marR="91440" marT="45720" marB="45720">
-                    <a:solidFill>
-                      <a:srgbClr val="EAF5FB"/>
-                    </a:solidFill>
-                  </a:tcPr>
-                </a:tc>
-                <a:tc>
-                  <a:txBody>
-                    <a:bodyPr/>
-                    <a:lstStyle/>
-                    <a:p>
-                      <a:r>
-                        <a:rPr sz="1275" b="1">
-                          <a:solidFill>
-                            <a:srgbClr val="111111"/>
-                          </a:solidFill>
-                        </a:rPr>
-                        <a:t>Grade</a:t>
-                      </a:r>
-                    </a:p>
-                  </a:txBody>
-                  <a:tcPr marL="91440" marR="91440" marT="45720" marB="45720">
-                    <a:solidFill>
-                      <a:srgbClr val="EAF5FB"/>
-                    </a:solidFill>
-                  </a:tcPr>
-                </a:tc>
-                <a:tc>
-                  <a:txBody>
-                    <a:bodyPr/>
-                    <a:lstStyle/>
-                    <a:p>
-                      <a:r>
-                        <a:rPr sz="1275" b="1">
-                          <a:solidFill>
-                            <a:srgbClr val="111111"/>
-                          </a:solidFill>
-                        </a:rPr>
-                        <a:t>Result File</a:t>
-                      </a:r>
-                    </a:p>
-                  </a:txBody>
-                  <a:tcPr marL="91440" marR="91440" marT="45720" marB="45720">
-                    <a:solidFill>
-                      <a:srgbClr val="EAF5FB"/>
-                    </a:solidFill>
-                  </a:tcPr>
-                </a:tc>
-                <a:tc>
-                  <a:txBody>
-                    <a:bodyPr/>
-                    <a:lstStyle/>
-                    <a:p>
-                      <a:r>
-                        <a:rPr sz="1275" b="1">
-                          <a:solidFill>
-                            <a:srgbClr val="111111"/>
-                          </a:solidFill>
-                        </a:rPr>
-                        <a:t>Status</a:t>
-                      </a:r>
-                    </a:p>
-                  </a:txBody>
-                  <a:tcPr marL="91440" marR="91440" marT="45720" marB="45720">
-                    <a:solidFill>
-                      <a:srgbClr val="EAF5FB"/>
-                    </a:solidFill>
-                  </a:tcPr>
-                </a:tc>
-              </a:tr>
-              <a:tr h="352425">
-                <a:tc>
-                  <a:txBody>
-                    <a:bodyPr/>
-                    <a:lstStyle/>
-                    <a:p>
-                      <a:r>
-                        <a:rPr sz="1125">
-                          <a:solidFill>
-                            <a:srgbClr val="111111"/>
-                          </a:solidFill>
-                        </a:rPr>
-                        <a:t>util</a:t>
-                      </a:r>
-                    </a:p>
-                  </a:txBody>
-                  <a:tcPr marL="76200" marR="76200" marT="38100" marB="38100"/>
-                </a:tc>
-                <a:tc>
-                  <a:txBody>
-                    <a:bodyPr/>
-                    <a:lstStyle/>
-                    <a:p>
-                      <a:r>
-                        <a:rPr sz="1125">
-                          <a:solidFill>
-                            <a:srgbClr val="111111"/>
-                          </a:solidFill>
-                        </a:rPr>
-                        <a:t>100/100</a:t>
-                      </a:r>
-                    </a:p>
-                  </a:txBody>
-                  <a:tcPr marL="76200" marR="76200" marT="38100" marB="38100"/>
-                </a:tc>
-                <a:tc>
-                  <a:txBody>
-                    <a:bodyPr/>
-                    <a:lstStyle/>
-                    <a:p>
-                      <a:r>
-                        <a:rPr sz="1125">
-                          <a:solidFill>
-                            <a:srgbClr val="111111"/>
-                          </a:solidFill>
-                        </a:rPr>
-                        <a:t>results/util/grade.txt</a:t>
-                      </a:r>
-                    </a:p>
-                  </a:txBody>
-                  <a:tcPr marL="76200" marR="76200" marT="38100" marB="38100"/>
-                </a:tc>
-                <a:tc>
-                  <a:txBody>
-                    <a:bodyPr/>
-                    <a:lstStyle/>
-                    <a:p>
-                      <a:r>
-                        <a:rPr sz="1125">
-                          <a:solidFill>
-                            <a:srgbClr val="111111"/>
-                          </a:solidFill>
-                        </a:rPr>
-                        <a:t>PASS</a:t>
-                      </a:r>
-                    </a:p>
-                  </a:txBody>
-                  <a:tcPr marL="76200" marR="76200" marT="38100" marB="38100"/>
-                </a:tc>
-              </a:tr>
-              <a:tr h="352425">
-                <a:tc>
-                  <a:txBody>
-                    <a:bodyPr/>
-                    <a:lstStyle/>
-                    <a:p>
-                      <a:r>
-                        <a:rPr sz="1125">
-                          <a:solidFill>
-                            <a:srgbClr val="111111"/>
-                          </a:solidFill>
-                        </a:rPr>
-                        <a:t>syscall</a:t>
-                      </a:r>
-                    </a:p>
-                  </a:txBody>
-                  <a:tcPr marL="76200" marR="76200" marT="38100" marB="38100"/>
-                </a:tc>
-                <a:tc>
-                  <a:txBody>
-                    <a:bodyPr/>
-                    <a:lstStyle/>
-                    <a:p>
-                      <a:r>
-                        <a:rPr sz="1125">
-                          <a:solidFill>
-                            <a:srgbClr val="111111"/>
-                          </a:solidFill>
-                        </a:rPr>
-                        <a:t>35/35</a:t>
-                      </a:r>
-                    </a:p>
-                  </a:txBody>
-                  <a:tcPr marL="76200" marR="76200" marT="38100" marB="38100"/>
-                </a:tc>
-                <a:tc>
-                  <a:txBody>
-                    <a:bodyPr/>
-                    <a:lstStyle/>
-                    <a:p>
-                      <a:r>
-                        <a:rPr sz="1125">
-                          <a:solidFill>
-                            <a:srgbClr val="111111"/>
-                          </a:solidFill>
-                        </a:rPr>
-                        <a:t>results/syscall/grade.txt</a:t>
-                      </a:r>
-                    </a:p>
-                  </a:txBody>
-                  <a:tcPr marL="76200" marR="76200" marT="38100" marB="38100"/>
-                </a:tc>
-                <a:tc>
-                  <a:txBody>
-                    <a:bodyPr/>
-                    <a:lstStyle/>
-                    <a:p>
-                      <a:r>
-                        <a:rPr sz="1125">
-                          <a:solidFill>
-                            <a:srgbClr val="111111"/>
-                          </a:solidFill>
-                        </a:rPr>
-                        <a:t>PASS</a:t>
-                      </a:r>
-                    </a:p>
-                  </a:txBody>
-                  <a:tcPr marL="76200" marR="76200" marT="38100" marB="38100"/>
-                </a:tc>
-              </a:tr>
-              <a:tr h="352425">
-                <a:tc>
-                  <a:txBody>
-                    <a:bodyPr/>
-                    <a:lstStyle/>
-                    <a:p>
-                      <a:r>
-                        <a:rPr sz="1125">
-                          <a:solidFill>
-                            <a:srgbClr val="111111"/>
-                          </a:solidFill>
-                        </a:rPr>
-                        <a:t>pgtbl</a:t>
-                      </a:r>
-                    </a:p>
-                  </a:txBody>
-                  <a:tcPr marL="76200" marR="76200" marT="38100" marB="38100"/>
-                </a:tc>
-                <a:tc>
-                  <a:txBody>
-                    <a:bodyPr/>
-                    <a:lstStyle/>
-                    <a:p>
-                      <a:r>
-                        <a:rPr sz="1125">
-                          <a:solidFill>
-                            <a:srgbClr val="111111"/>
-                          </a:solidFill>
-                        </a:rPr>
-                        <a:t>46/46</a:t>
-                      </a:r>
-                    </a:p>
-                  </a:txBody>
-                  <a:tcPr marL="76200" marR="76200" marT="38100" marB="38100"/>
-                </a:tc>
-                <a:tc>
-                  <a:txBody>
-                    <a:bodyPr/>
-                    <a:lstStyle/>
-                    <a:p>
-                      <a:r>
-                        <a:rPr sz="1125">
-                          <a:solidFill>
-                            <a:srgbClr val="111111"/>
-                          </a:solidFill>
-                        </a:rPr>
-                        <a:t>results/pgtbl/grade.txt</a:t>
-                      </a:r>
-                    </a:p>
-                  </a:txBody>
-                  <a:tcPr marL="76200" marR="76200" marT="38100" marB="38100"/>
-                </a:tc>
-                <a:tc>
-                  <a:txBody>
-                    <a:bodyPr/>
-                    <a:lstStyle/>
-                    <a:p>
-                      <a:r>
-                        <a:rPr sz="1125">
-                          <a:solidFill>
-                            <a:srgbClr val="111111"/>
-                          </a:solidFill>
-                        </a:rPr>
-                        <a:t>PASS</a:t>
-                      </a:r>
-                    </a:p>
-                  </a:txBody>
-                  <a:tcPr marL="76200" marR="76200" marT="38100" marB="38100"/>
-                </a:tc>
-              </a:tr>
-              <a:tr h="352425">
-                <a:tc>
-                  <a:txBody>
-                    <a:bodyPr/>
-                    <a:lstStyle/>
-                    <a:p>
-                      <a:r>
-                        <a:rPr sz="1125">
-                          <a:solidFill>
-                            <a:srgbClr val="111111"/>
-                          </a:solidFill>
-                        </a:rPr>
-                        <a:t>traps</a:t>
-                      </a:r>
-                    </a:p>
-                  </a:txBody>
-                  <a:tcPr marL="76200" marR="76200" marT="38100" marB="38100"/>
-                </a:tc>
-                <a:tc>
-                  <a:txBody>
-                    <a:bodyPr/>
-                    <a:lstStyle/>
-                    <a:p>
-                      <a:r>
-                        <a:rPr sz="1125">
-                          <a:solidFill>
-                            <a:srgbClr val="111111"/>
-                          </a:solidFill>
-                        </a:rPr>
-                        <a:t>85/85</a:t>
-                      </a:r>
-                    </a:p>
-                  </a:txBody>
-                  <a:tcPr marL="76200" marR="76200" marT="38100" marB="38100"/>
-                </a:tc>
-                <a:tc>
-                  <a:txBody>
-                    <a:bodyPr/>
-                    <a:lstStyle/>
-                    <a:p>
-                      <a:r>
-                        <a:rPr sz="1125">
-                          <a:solidFill>
-                            <a:srgbClr val="111111"/>
-                          </a:solidFill>
-                        </a:rPr>
-                        <a:t>results/traps/grade.txt</a:t>
-                      </a:r>
-                    </a:p>
-                  </a:txBody>
-                  <a:tcPr marL="76200" marR="76200" marT="38100" marB="38100"/>
-                </a:tc>
-                <a:tc>
-                  <a:txBody>
-                    <a:bodyPr/>
-                    <a:lstStyle/>
-                    <a:p>
-                      <a:r>
-                        <a:rPr sz="1125">
-                          <a:solidFill>
-                            <a:srgbClr val="111111"/>
-                          </a:solidFill>
-                        </a:rPr>
-                        <a:t>PASS</a:t>
-                      </a:r>
-                    </a:p>
-                  </a:txBody>
-                  <a:tcPr marL="76200" marR="76200" marT="38100" marB="38100"/>
-                </a:tc>
-              </a:tr>
-              <a:tr h="352425">
-                <a:tc>
-                  <a:txBody>
-                    <a:bodyPr/>
-                    <a:lstStyle/>
-                    <a:p>
-                      <a:r>
-                        <a:rPr sz="1125">
-                          <a:solidFill>
-                            <a:srgbClr val="111111"/>
-                          </a:solidFill>
-                        </a:rPr>
-                        <a:t>cow</a:t>
-                      </a:r>
-                    </a:p>
-                  </a:txBody>
-                  <a:tcPr marL="76200" marR="76200" marT="38100" marB="38100"/>
-                </a:tc>
-                <a:tc>
-                  <a:txBody>
-                    <a:bodyPr/>
-                    <a:lstStyle/>
-                    <a:p>
-                      <a:r>
-                        <a:rPr sz="1125">
-                          <a:solidFill>
-                            <a:srgbClr val="111111"/>
-                          </a:solidFill>
-                        </a:rPr>
-                        <a:t>110/110</a:t>
-                      </a:r>
-                    </a:p>
-                  </a:txBody>
-                  <a:tcPr marL="76200" marR="76200" marT="38100" marB="38100"/>
-                </a:tc>
-                <a:tc>
-                  <a:txBody>
-                    <a:bodyPr/>
-                    <a:lstStyle/>
-                    <a:p>
-                      <a:r>
-                        <a:rPr sz="1125">
-                          <a:solidFill>
-                            <a:srgbClr val="111111"/>
-                          </a:solidFill>
-                        </a:rPr>
-                        <a:t>results/cow/grade.txt</a:t>
-                      </a:r>
-                    </a:p>
-                  </a:txBody>
-                  <a:tcPr marL="76200" marR="76200" marT="38100" marB="38100"/>
-                </a:tc>
-                <a:tc>
-                  <a:txBody>
-                    <a:bodyPr/>
-                    <a:lstStyle/>
-                    <a:p>
-                      <a:r>
-                        <a:rPr sz="1125">
-                          <a:solidFill>
-                            <a:srgbClr val="111111"/>
-                          </a:solidFill>
-                        </a:rPr>
-                        <a:t>PASS</a:t>
-                      </a:r>
-                    </a:p>
-                  </a:txBody>
-                  <a:tcPr marL="76200" marR="76200" marT="38100" marB="38100"/>
-                </a:tc>
-              </a:tr>
-              <a:tr h="352425">
-                <a:tc>
-                  <a:txBody>
-                    <a:bodyPr/>
-                    <a:lstStyle/>
-                    <a:p>
-                      <a:r>
-                        <a:rPr sz="1125">
-                          <a:solidFill>
-                            <a:srgbClr val="111111"/>
-                          </a:solidFill>
-                        </a:rPr>
-                        <a:t>thread</a:t>
-                      </a:r>
-                    </a:p>
-                  </a:txBody>
-                  <a:tcPr marL="76200" marR="76200" marT="38100" marB="38100"/>
-                </a:tc>
-                <a:tc>
-                  <a:txBody>
-                    <a:bodyPr/>
-                    <a:lstStyle/>
-                    <a:p>
-                      <a:r>
-                        <a:rPr sz="1125">
-                          <a:solidFill>
-                            <a:srgbClr val="111111"/>
-                          </a:solidFill>
-                        </a:rPr>
-                        <a:t>60/60</a:t>
-                      </a:r>
-                    </a:p>
-                  </a:txBody>
-                  <a:tcPr marL="76200" marR="76200" marT="38100" marB="38100"/>
-                </a:tc>
-                <a:tc>
-                  <a:txBody>
-                    <a:bodyPr/>
-                    <a:lstStyle/>
-                    <a:p>
-                      <a:r>
-                        <a:rPr sz="1125">
-                          <a:solidFill>
-                            <a:srgbClr val="111111"/>
-                          </a:solidFill>
-                        </a:rPr>
-                        <a:t>results/thread/grade.txt</a:t>
-                      </a:r>
-                    </a:p>
-                  </a:txBody>
-                  <a:tcPr marL="76200" marR="76200" marT="38100" marB="38100"/>
-                </a:tc>
-                <a:tc>
-                  <a:txBody>
-                    <a:bodyPr/>
-                    <a:lstStyle/>
-                    <a:p>
-                      <a:r>
-                        <a:rPr sz="1125">
-                          <a:solidFill>
-                            <a:srgbClr val="111111"/>
-                          </a:solidFill>
-                        </a:rPr>
-                        <a:t>PASS</a:t>
-                      </a:r>
-                    </a:p>
-                  </a:txBody>
-                  <a:tcPr marL="76200" marR="76200" marT="38100" marB="38100"/>
-                </a:tc>
-              </a:tr>
-              <a:tr h="352425">
-                <a:tc>
-                  <a:txBody>
-                    <a:bodyPr/>
-                    <a:lstStyle/>
-                    <a:p>
-                      <a:r>
-                        <a:rPr sz="1125">
-                          <a:solidFill>
-                            <a:srgbClr val="111111"/>
-                          </a:solidFill>
-                        </a:rPr>
-                        <a:t>net</a:t>
-                      </a:r>
-                    </a:p>
-                  </a:txBody>
-                  <a:tcPr marL="76200" marR="76200" marT="38100" marB="38100"/>
-                </a:tc>
-                <a:tc>
-                  <a:txBody>
-                    <a:bodyPr/>
-                    <a:lstStyle/>
-                    <a:p>
-                      <a:r>
-                        <a:rPr sz="1125">
-                          <a:solidFill>
-                            <a:srgbClr val="111111"/>
-                          </a:solidFill>
-                        </a:rPr>
-                        <a:t>100/100</a:t>
-                      </a:r>
-                    </a:p>
-                  </a:txBody>
-                  <a:tcPr marL="76200" marR="76200" marT="38100" marB="38100"/>
-                </a:tc>
-                <a:tc>
-                  <a:txBody>
-                    <a:bodyPr/>
-                    <a:lstStyle/>
-                    <a:p>
-                      <a:r>
-                        <a:rPr sz="1125">
-                          <a:solidFill>
-                            <a:srgbClr val="111111"/>
-                          </a:solidFill>
-                        </a:rPr>
-                        <a:t>results/net/grade.txt</a:t>
-                      </a:r>
-                    </a:p>
-                  </a:txBody>
-                  <a:tcPr marL="76200" marR="76200" marT="38100" marB="38100"/>
-                </a:tc>
-                <a:tc>
-                  <a:txBody>
-                    <a:bodyPr/>
-                    <a:lstStyle/>
-                    <a:p>
-                      <a:r>
-                        <a:rPr sz="1125">
-                          <a:solidFill>
-                            <a:srgbClr val="111111"/>
-                          </a:solidFill>
-                        </a:rPr>
-                        <a:t>PASS</a:t>
-                      </a:r>
-                    </a:p>
-                  </a:txBody>
-                  <a:tcPr marL="76200" marR="76200" marT="38100" marB="38100"/>
-                </a:tc>
-              </a:tr>
-              <a:tr h="352425">
-                <a:tc>
-                  <a:txBody>
-                    <a:bodyPr/>
-                    <a:lstStyle/>
-                    <a:p>
-                      <a:r>
-                        <a:rPr sz="1125">
-                          <a:solidFill>
-                            <a:srgbClr val="111111"/>
-                          </a:solidFill>
-                        </a:rPr>
-                        <a:t>lock</a:t>
-                      </a:r>
-                    </a:p>
-                  </a:txBody>
-                  <a:tcPr marL="76200" marR="76200" marT="38100" marB="38100"/>
-                </a:tc>
-                <a:tc>
-                  <a:txBody>
-                    <a:bodyPr/>
-                    <a:lstStyle/>
-                    <a:p>
-                      <a:r>
-                        <a:rPr sz="1125">
-                          <a:solidFill>
-                            <a:srgbClr val="111111"/>
-                          </a:solidFill>
-                        </a:rPr>
-                        <a:t>70/70</a:t>
-                      </a:r>
-                    </a:p>
-                  </a:txBody>
-                  <a:tcPr marL="76200" marR="76200" marT="38100" marB="38100"/>
-                </a:tc>
-                <a:tc>
-                  <a:txBody>
-                    <a:bodyPr/>
-                    <a:lstStyle/>
-                    <a:p>
-                      <a:r>
-                        <a:rPr sz="1125">
-                          <a:solidFill>
-                            <a:srgbClr val="111111"/>
-                          </a:solidFill>
-                        </a:rPr>
-                        <a:t>results/lock/grade.txt</a:t>
-                      </a:r>
-                    </a:p>
-                  </a:txBody>
-                  <a:tcPr marL="76200" marR="76200" marT="38100" marB="38100"/>
-                </a:tc>
-                <a:tc>
-                  <a:txBody>
-                    <a:bodyPr/>
-                    <a:lstStyle/>
-                    <a:p>
-                      <a:r>
-                        <a:rPr sz="1125">
-                          <a:solidFill>
-                            <a:srgbClr val="111111"/>
-                          </a:solidFill>
-                        </a:rPr>
-                        <a:t>PASS</a:t>
-                      </a:r>
-                    </a:p>
-                  </a:txBody>
-                  <a:tcPr marL="76200" marR="76200" marT="38100" marB="38100"/>
-                </a:tc>
-              </a:tr>
-              <a:tr h="352425">
-                <a:tc>
-                  <a:txBody>
-                    <a:bodyPr/>
-                    <a:lstStyle/>
-                    <a:p>
-                      <a:r>
-                        <a:rPr sz="1125">
-                          <a:solidFill>
-                            <a:srgbClr val="111111"/>
-                          </a:solidFill>
-                        </a:rPr>
-                        <a:t>fs</a:t>
-                      </a:r>
-                    </a:p>
-                  </a:txBody>
-                  <a:tcPr marL="76200" marR="76200" marT="38100" marB="38100"/>
-                </a:tc>
-                <a:tc>
-                  <a:txBody>
-                    <a:bodyPr/>
-                    <a:lstStyle/>
-                    <a:p>
-                      <a:r>
-                        <a:rPr sz="1125">
-                          <a:solidFill>
-                            <a:srgbClr val="111111"/>
-                          </a:solidFill>
-                        </a:rPr>
-                        <a:t>100/100</a:t>
-                      </a:r>
-                    </a:p>
-                  </a:txBody>
-                  <a:tcPr marL="76200" marR="76200" marT="38100" marB="38100"/>
-                </a:tc>
-                <a:tc>
-                  <a:txBody>
-                    <a:bodyPr/>
-                    <a:lstStyle/>
-                    <a:p>
-                      <a:r>
-                        <a:rPr sz="1125">
-                          <a:solidFill>
-                            <a:srgbClr val="111111"/>
-                          </a:solidFill>
-                        </a:rPr>
-                        <a:t>results/fs/grade.txt</a:t>
-                      </a:r>
-                    </a:p>
-                  </a:txBody>
-                  <a:tcPr marL="76200" marR="76200" marT="38100" marB="38100"/>
-                </a:tc>
-                <a:tc>
-                  <a:txBody>
-                    <a:bodyPr/>
-                    <a:lstStyle/>
-                    <a:p>
-                      <a:r>
-                        <a:rPr sz="1125">
-                          <a:solidFill>
-                            <a:srgbClr val="111111"/>
-                          </a:solidFill>
-                        </a:rPr>
-                        <a:t>PASS</a:t>
-                      </a:r>
-                    </a:p>
-                  </a:txBody>
-                  <a:tcPr marL="76200" marR="76200" marT="38100" marB="38100"/>
-                </a:tc>
-              </a:tr>
-              <a:tr h="352425">
-                <a:tc>
-                  <a:txBody>
-                    <a:bodyPr/>
-                    <a:lstStyle/>
-                    <a:p>
-                      <a:r>
-                        <a:rPr sz="1125">
-                          <a:solidFill>
-                            <a:srgbClr val="111111"/>
-                          </a:solidFill>
-                        </a:rPr>
-                        <a:t>mmap</a:t>
-                      </a:r>
-                    </a:p>
-                  </a:txBody>
-                  <a:tcPr marL="76200" marR="76200" marT="38100" marB="38100"/>
-                </a:tc>
-                <a:tc>
-                  <a:txBody>
-                    <a:bodyPr/>
-                    <a:lstStyle/>
-                    <a:p>
-                      <a:r>
-                        <a:rPr sz="1125">
-                          <a:solidFill>
-                            <a:srgbClr val="111111"/>
-                          </a:solidFill>
-                        </a:rPr>
-                        <a:t>140/140</a:t>
-                      </a:r>
-                    </a:p>
-                  </a:txBody>
-                  <a:tcPr marL="76200" marR="76200" marT="38100" marB="38100"/>
-                </a:tc>
-                <a:tc>
-                  <a:txBody>
-                    <a:bodyPr/>
-                    <a:lstStyle/>
-                    <a:p>
-                      <a:r>
-                        <a:rPr sz="1125">
-                          <a:solidFill>
-                            <a:srgbClr val="111111"/>
-                          </a:solidFill>
-                        </a:rPr>
-                        <a:t>results/mmap/grade.txt</a:t>
-                      </a:r>
-                    </a:p>
-                  </a:txBody>
-                  <a:tcPr marL="76200" marR="76200" marT="38100" marB="38100"/>
-                </a:tc>
-                <a:tc>
-                  <a:txBody>
-                    <a:bodyPr/>
-                    <a:lstStyle/>
-                    <a:p>
-                      <a:r>
-                        <a:rPr sz="1125">
-                          <a:solidFill>
-                            <a:srgbClr val="111111"/>
-                          </a:solidFill>
-                        </a:rPr>
-                        <a:t>PASS</a:t>
-                      </a:r>
-                    </a:p>
-                  </a:txBody>
-                  <a:tcPr marL="76200" marR="76200" marT="38100" marB="38100"/>
-                </a:tc>
-              </a:tr>
-              <a:tr h="352425">
-                <a:tc>
-                  <a:txBody>
-                    <a:bodyPr/>
-                    <a:lstStyle/>
-                    <a:p>
-                      <a:r>
-                        <a:rPr sz="1125">
-                          <a:solidFill>
-                            <a:srgbClr val="111111"/>
-                          </a:solidFill>
-                        </a:rPr>
-                        <a:t>Total</a:t>
-                      </a:r>
-                    </a:p>
-                  </a:txBody>
-                  <a:tcPr marL="76200" marR="76200" marT="38100" marB="38100"/>
-                </a:tc>
-                <a:tc>
-                  <a:txBody>
-                    <a:bodyPr/>
-                    <a:lstStyle/>
-                    <a:p>
-                      <a:r>
-                        <a:rPr sz="1125">
-                          <a:solidFill>
-                            <a:srgbClr val="111111"/>
-                          </a:solidFill>
-                        </a:rPr>
-                        <a:t>846/846</a:t>
-                      </a:r>
-                    </a:p>
-                  </a:txBody>
-                  <a:tcPr marL="76200" marR="76200" marT="38100" marB="38100"/>
-                </a:tc>
-                <a:tc>
-                  <a:txBody>
-                    <a:bodyPr/>
-                    <a:lstStyle/>
-                    <a:p>
-                      <a:r>
-                        <a:rPr sz="1125">
-                          <a:solidFill>
-                            <a:srgbClr val="111111"/>
-                          </a:solidFill>
-                        </a:rPr>
-                        <a:t>results/</a:t>
-                      </a:r>
-                    </a:p>
-                  </a:txBody>
-                  <a:tcPr marL="76200" marR="76200" marT="38100" marB="38100"/>
-                </a:tc>
-                <a:tc>
-                  <a:txBody>
-                    <a:bodyPr/>
-                    <a:lstStyle/>
-                    <a:p>
-                      <a:r>
-                        <a:rPr sz="1125">
-                          <a:solidFill>
-                            <a:srgbClr val="111111"/>
-                          </a:solidFill>
-                        </a:rPr>
-                        <a:t>PASS</a:t>
-                      </a:r>
-                    </a:p>
-                  </a:txBody>
-                  <a:tcPr marL="76200" marR="76200" marT="38100" marB="38100"/>
-                </a:tc>
-              </a:tr>
-            </a:tbl>
-          </a:graphicData>
-        </a:graphic>
-      </p:graphicFrame>
+      <p:pic>
+        <p:nvPicPr>
+          <p:cNvPr id="12" name=""/>
+          <p:cNvPicPr>
+            <a:picLocks xmlns:a="http://schemas.openxmlformats.org/drawingml/2006/main" noChangeAspect="1"/>
+          </p:cNvPicPr>
+          <p:nvPr/>
+        </p:nvPicPr>
+        <p:blipFill>
+          <a:blip xmlns:r="http://schemas.openxmlformats.org/officeDocument/2006/relationships" xmlns:a="http://schemas.openxmlformats.org/drawingml/2006/main" r:embed="R194792e07bee4598"/>
+          <a:stretch xmlns:a="http://schemas.openxmlformats.org/drawingml/2006/main"/>
+        </p:blipFill>
+        <p:spPr>
+          <a:xfrm xmlns:a="http://schemas.openxmlformats.org/drawingml/2006/main">
+            <a:off x="3589867" y="1638300"/>
+            <a:ext cx="5012267" cy="4229100"/>
+          </a:xfrm>
+          <a:prstGeom xmlns:a="http://schemas.openxmlformats.org/drawingml/2006/main" prst="rect">
+            <a:avLst/>
+          </a:prstGeom>
+        </p:spPr>
+      </p:pic>
     </p:spTree>
     <p:extLst>
       <p:ext uri="{BB962C8B-B14F-4D97-AF65-F5344CB8AC3E}">
@@ -6118,6 +5232,7 @@
           <a:lstStyle xmlns:a="http://schemas.openxmlformats.org/drawingml/2006/main"/>
           <a:p xmlns:a="http://schemas.openxmlformats.org/drawingml/2006/main">
             <a:pPr algn="l">
+              <a:buNone/>
               <a:defRPr sz="1050" b="1">
                 <a:solidFill>
                   <a:srgbClr val="5F6368"/>
@@ -6168,6 +5283,7 @@
           <a:lstStyle xmlns:a="http://schemas.openxmlformats.org/drawingml/2006/main"/>
           <a:p xmlns:a="http://schemas.openxmlformats.org/drawingml/2006/main">
             <a:pPr algn="l">
+              <a:buNone/>
               <a:defRPr sz="2850" b="1">
                 <a:solidFill>
                   <a:srgbClr val="111111"/>
@@ -6218,6 +5334,7 @@
           <a:lstStyle xmlns:a="http://schemas.openxmlformats.org/drawingml/2006/main"/>
           <a:p xmlns:a="http://schemas.openxmlformats.org/drawingml/2006/main">
             <a:pPr algn="r">
+              <a:buNone/>
               <a:defRPr sz="1050" b="0">
                 <a:solidFill>
                   <a:srgbClr val="5F6368"/>
@@ -6268,7 +5385,7 @@
       </p:sp>
       <p:graphicFrame>
         <p:nvGraphicFramePr>
-          <p:cNvPr id="11" name=""/>
+          <p:cNvPr id="13" name=""/>
           <p:cNvGraphicFramePr/>
           <p:nvPr/>
         </p:nvGraphicFramePr>
@@ -6899,6 +6016,7 @@
           <a:lstStyle xmlns:a="http://schemas.openxmlformats.org/drawingml/2006/main"/>
           <a:p xmlns:a="http://schemas.openxmlformats.org/drawingml/2006/main">
             <a:pPr algn="ctr">
+              <a:buNone/>
               <a:defRPr sz="1500" b="1">
                 <a:solidFill>
                   <a:srgbClr val="1F4E79"/>
@@ -6971,6 +6089,7 @@
           <a:lstStyle xmlns:a="http://schemas.openxmlformats.org/drawingml/2006/main"/>
           <a:p xmlns:a="http://schemas.openxmlformats.org/drawingml/2006/main">
             <a:pPr algn="l">
+              <a:buNone/>
               <a:defRPr sz="1050" b="1">
                 <a:solidFill>
                   <a:srgbClr val="1F4E79"/>
@@ -7021,6 +6140,7 @@
           <a:lstStyle xmlns:a="http://schemas.openxmlformats.org/drawingml/2006/main"/>
           <a:p xmlns:a="http://schemas.openxmlformats.org/drawingml/2006/main">
             <a:pPr algn="l">
+              <a:buNone/>
               <a:defRPr sz="2850" b="1">
                 <a:solidFill>
                   <a:srgbClr val="111111"/>
@@ -7071,6 +6191,7 @@
           <a:lstStyle xmlns:a="http://schemas.openxmlformats.org/drawingml/2006/main"/>
           <a:p xmlns:a="http://schemas.openxmlformats.org/drawingml/2006/main">
             <a:pPr algn="r">
+              <a:buNone/>
               <a:defRPr sz="1050" b="0">
                 <a:solidFill>
                   <a:srgbClr val="5F6368"/>
@@ -7152,6 +6273,7 @@
           <a:lstStyle xmlns:a="http://schemas.openxmlformats.org/drawingml/2006/main"/>
           <a:p xmlns:a="http://schemas.openxmlformats.org/drawingml/2006/main">
             <a:pPr algn="l">
+              <a:buNone/>
               <a:defRPr sz="4500" b="1">
                 <a:solidFill>
                   <a:srgbClr val="3D8DFF"/>
@@ -7202,6 +6324,7 @@
           <a:lstStyle xmlns:a="http://schemas.openxmlformats.org/drawingml/2006/main"/>
           <a:p xmlns:a="http://schemas.openxmlformats.org/drawingml/2006/main">
             <a:pPr algn="l">
+              <a:buNone/>
               <a:defRPr sz="1500" b="0">
                 <a:solidFill>
                   <a:srgbClr val="5F6368"/>
@@ -7252,6 +6375,7 @@
           <a:lstStyle xmlns:a="http://schemas.openxmlformats.org/drawingml/2006/main"/>
           <a:p xmlns:a="http://schemas.openxmlformats.org/drawingml/2006/main">
             <a:pPr algn="l">
+              <a:buNone/>
               <a:defRPr sz="4500" b="1">
                 <a:solidFill>
                   <a:srgbClr val="1F4E79"/>
@@ -7302,6 +6426,7 @@
           <a:lstStyle xmlns:a="http://schemas.openxmlformats.org/drawingml/2006/main"/>
           <a:p xmlns:a="http://schemas.openxmlformats.org/drawingml/2006/main">
             <a:pPr algn="l">
+              <a:buNone/>
               <a:defRPr sz="1500" b="0">
                 <a:solidFill>
                   <a:srgbClr val="5F6368"/>
@@ -7352,6 +6477,7 @@
           <a:lstStyle xmlns:a="http://schemas.openxmlformats.org/drawingml/2006/main"/>
           <a:p xmlns:a="http://schemas.openxmlformats.org/drawingml/2006/main">
             <a:pPr algn="l">
+              <a:buNone/>
               <a:defRPr sz="1875" b="1">
                 <a:solidFill>
                   <a:srgbClr val="111111"/>
@@ -7402,6 +6528,7 @@
           <a:lstStyle xmlns:a="http://schemas.openxmlformats.org/drawingml/2006/main"/>
           <a:p xmlns:a="http://schemas.openxmlformats.org/drawingml/2006/main">
             <a:pPr algn="l">
+              <a:buNone/>
               <a:defRPr sz="1575" b="0">
                 <a:solidFill>
                   <a:srgbClr val="111111"/>
@@ -7419,6 +6546,7 @@
           </a:p>
           <a:p xmlns:a="http://schemas.openxmlformats.org/drawingml/2006/main">
             <a:pPr algn="l">
+              <a:buNone/>
               <a:defRPr sz="1575" b="0">
                 <a:solidFill>
                   <a:srgbClr val="111111"/>
@@ -7436,6 +6564,7 @@
           </a:p>
           <a:p xmlns:a="http://schemas.openxmlformats.org/drawingml/2006/main">
             <a:pPr algn="l">
+              <a:buNone/>
               <a:defRPr sz="1575" b="0">
                 <a:solidFill>
                   <a:srgbClr val="111111"/>
@@ -7453,6 +6582,7 @@
           </a:p>
           <a:p xmlns:a="http://schemas.openxmlformats.org/drawingml/2006/main">
             <a:pPr algn="l">
+              <a:buNone/>
               <a:defRPr sz="1575" b="0">
                 <a:solidFill>
                   <a:srgbClr val="111111"/>
@@ -7472,7 +6602,7 @@
       </p:sp>
       <p:graphicFrame>
         <p:nvGraphicFramePr>
-          <p:cNvPr id="22" name=""/>
+          <p:cNvPr id="24" name=""/>
           <p:cNvGraphicFramePr/>
           <p:nvPr/>
         </p:nvGraphicFramePr>
@@ -7985,6 +7115,7 @@
           <a:lstStyle xmlns:a="http://schemas.openxmlformats.org/drawingml/2006/main"/>
           <a:p xmlns:a="http://schemas.openxmlformats.org/drawingml/2006/main">
             <a:pPr algn="l">
+              <a:buNone/>
               <a:defRPr sz="1050" b="1">
                 <a:solidFill>
                   <a:srgbClr val="1F4E79"/>
@@ -8035,6 +7166,7 @@
           <a:lstStyle xmlns:a="http://schemas.openxmlformats.org/drawingml/2006/main"/>
           <a:p xmlns:a="http://schemas.openxmlformats.org/drawingml/2006/main">
             <a:pPr algn="l">
+              <a:buNone/>
               <a:defRPr sz="2850" b="1">
                 <a:solidFill>
                   <a:srgbClr val="111111"/>
@@ -8085,6 +7217,7 @@
           <a:lstStyle xmlns:a="http://schemas.openxmlformats.org/drawingml/2006/main"/>
           <a:p xmlns:a="http://schemas.openxmlformats.org/drawingml/2006/main">
             <a:pPr algn="r">
+              <a:buNone/>
               <a:defRPr sz="1050" b="0">
                 <a:solidFill>
                   <a:srgbClr val="5F6368"/>
@@ -8135,14 +7268,14 @@
       </p:sp>
       <p:pic>
         <p:nvPicPr>
-          <p:cNvPr id="13" name=""/>
+          <p:cNvPr id="15" name=""/>
           <p:cNvPicPr>
             <a:picLocks xmlns:a="http://schemas.openxmlformats.org/drawingml/2006/main" noChangeAspect="1"/>
           </p:cNvPicPr>
           <p:nvPr/>
         </p:nvPicPr>
         <p:blipFill>
-          <a:blip xmlns:r="http://schemas.openxmlformats.org/officeDocument/2006/relationships" xmlns:a="http://schemas.openxmlformats.org/drawingml/2006/main" r:embed="Rc94f43f64ec144f5"/>
+          <a:blip xmlns:r="http://schemas.openxmlformats.org/officeDocument/2006/relationships" xmlns:a="http://schemas.openxmlformats.org/drawingml/2006/main" r:embed="R9b44a8cd6939425f"/>
           <a:stretch xmlns:a="http://schemas.openxmlformats.org/drawingml/2006/main"/>
         </p:blipFill>
         <p:spPr>
@@ -8188,6 +7321,7 @@
           <a:lstStyle xmlns:a="http://schemas.openxmlformats.org/drawingml/2006/main"/>
           <a:p xmlns:a="http://schemas.openxmlformats.org/drawingml/2006/main">
             <a:pPr algn="l">
+              <a:buNone/>
               <a:defRPr sz="1800" b="1">
                 <a:solidFill>
                   <a:srgbClr val="1F4E79"/>
@@ -8238,6 +7372,7 @@
           <a:lstStyle xmlns:a="http://schemas.openxmlformats.org/drawingml/2006/main"/>
           <a:p xmlns:a="http://schemas.openxmlformats.org/drawingml/2006/main">
             <a:pPr algn="l">
+              <a:buNone/>
               <a:defRPr sz="1500" b="0">
                 <a:solidFill>
                   <a:srgbClr val="111111"/>
@@ -8255,6 +7390,7 @@
           </a:p>
           <a:p xmlns:a="http://schemas.openxmlformats.org/drawingml/2006/main">
             <a:pPr algn="l">
+              <a:buNone/>
               <a:defRPr sz="1500" b="0">
                 <a:solidFill>
                   <a:srgbClr val="111111"/>
@@ -8272,6 +7408,7 @@
           </a:p>
           <a:p xmlns:a="http://schemas.openxmlformats.org/drawingml/2006/main">
             <a:pPr algn="l">
+              <a:buNone/>
               <a:defRPr sz="1500" b="0">
                 <a:solidFill>
                   <a:srgbClr val="111111"/>
@@ -8322,6 +7459,7 @@
           <a:lstStyle xmlns:a="http://schemas.openxmlformats.org/drawingml/2006/main"/>
           <a:p xmlns:a="http://schemas.openxmlformats.org/drawingml/2006/main">
             <a:pPr algn="l">
+              <a:buNone/>
               <a:defRPr sz="1800" b="1">
                 <a:solidFill>
                   <a:srgbClr val="111111"/>
@@ -8394,6 +7532,7 @@
           <a:lstStyle xmlns:a="http://schemas.openxmlformats.org/drawingml/2006/main"/>
           <a:p xmlns:a="http://schemas.openxmlformats.org/drawingml/2006/main">
             <a:pPr algn="l">
+              <a:buNone/>
               <a:defRPr sz="1050" b="1">
                 <a:solidFill>
                   <a:srgbClr val="1F4E79"/>
@@ -8444,6 +7583,7 @@
           <a:lstStyle xmlns:a="http://schemas.openxmlformats.org/drawingml/2006/main"/>
           <a:p xmlns:a="http://schemas.openxmlformats.org/drawingml/2006/main">
             <a:pPr algn="l">
+              <a:buNone/>
               <a:defRPr sz="2850" b="1">
                 <a:solidFill>
                   <a:srgbClr val="111111"/>
@@ -8494,6 +7634,7 @@
           <a:lstStyle xmlns:a="http://schemas.openxmlformats.org/drawingml/2006/main"/>
           <a:p xmlns:a="http://schemas.openxmlformats.org/drawingml/2006/main">
             <a:pPr algn="r">
+              <a:buNone/>
               <a:defRPr sz="1050" b="0">
                 <a:solidFill>
                   <a:srgbClr val="5F6368"/>
@@ -8581,6 +7722,7 @@
           <a:lstStyle xmlns:a="http://schemas.openxmlformats.org/drawingml/2006/main"/>
           <a:p xmlns:a="http://schemas.openxmlformats.org/drawingml/2006/main">
             <a:pPr algn="ctr">
+              <a:buNone/>
               <a:defRPr sz="1275" b="1">
                 <a:solidFill>
                   <a:srgbClr val="111111"/>
@@ -8637,6 +7779,7 @@
           <a:lstStyle xmlns:a="http://schemas.openxmlformats.org/drawingml/2006/main"/>
           <a:p xmlns:a="http://schemas.openxmlformats.org/drawingml/2006/main">
             <a:pPr algn="ctr">
+              <a:buNone/>
               <a:defRPr sz="1275" b="1">
                 <a:solidFill>
                   <a:srgbClr val="111111"/>
@@ -8693,6 +7836,7 @@
           <a:lstStyle xmlns:a="http://schemas.openxmlformats.org/drawingml/2006/main"/>
           <a:p xmlns:a="http://schemas.openxmlformats.org/drawingml/2006/main">
             <a:pPr algn="ctr">
+              <a:buNone/>
               <a:defRPr sz="1275" b="1">
                 <a:solidFill>
                   <a:srgbClr val="111111"/>
@@ -8749,6 +7893,7 @@
           <a:lstStyle xmlns:a="http://schemas.openxmlformats.org/drawingml/2006/main"/>
           <a:p xmlns:a="http://schemas.openxmlformats.org/drawingml/2006/main">
             <a:pPr algn="ctr">
+              <a:buNone/>
               <a:defRPr sz="1275" b="1">
                 <a:solidFill>
                   <a:srgbClr val="111111"/>
@@ -8805,6 +7950,7 @@
           <a:lstStyle xmlns:a="http://schemas.openxmlformats.org/drawingml/2006/main"/>
           <a:p xmlns:a="http://schemas.openxmlformats.org/drawingml/2006/main">
             <a:pPr algn="ctr">
+              <a:buNone/>
               <a:defRPr sz="1275" b="1">
                 <a:solidFill>
                   <a:srgbClr val="111111"/>
@@ -8861,6 +8007,7 @@
           <a:lstStyle xmlns:a="http://schemas.openxmlformats.org/drawingml/2006/main"/>
           <a:p xmlns:a="http://schemas.openxmlformats.org/drawingml/2006/main">
             <a:pPr algn="ctr">
+              <a:buNone/>
               <a:defRPr sz="1275" b="1">
                 <a:solidFill>
                   <a:srgbClr val="111111"/>
@@ -8880,7 +8027,7 @@
       </p:sp>
       <p:cxnSp>
         <p:nvCxnSpPr>
-          <p:cNvPr id="30" name=""/>
+          <p:cNvPr id="60" name=""/>
           <p:cNvCxnSpPr>
             <a:stCxn xmlns:a="http://schemas.openxmlformats.org/drawingml/2006/main" id="5" idx="3"/>
             <a:endCxn xmlns:a="http://schemas.openxmlformats.org/drawingml/2006/main" id="6" idx="1"/>
@@ -8906,7 +8053,7 @@
       </p:cxnSp>
       <p:cxnSp>
         <p:nvCxnSpPr>
-          <p:cNvPr id="31" name=""/>
+          <p:cNvPr id="61" name=""/>
           <p:cNvCxnSpPr>
             <a:stCxn xmlns:a="http://schemas.openxmlformats.org/drawingml/2006/main" id="6" idx="3"/>
             <a:endCxn xmlns:a="http://schemas.openxmlformats.org/drawingml/2006/main" id="7" idx="1"/>
@@ -8932,7 +8079,7 @@
       </p:cxnSp>
       <p:cxnSp>
         <p:nvCxnSpPr>
-          <p:cNvPr id="32" name=""/>
+          <p:cNvPr id="62" name=""/>
           <p:cNvCxnSpPr>
             <a:stCxn xmlns:a="http://schemas.openxmlformats.org/drawingml/2006/main" id="7" idx="3"/>
             <a:endCxn xmlns:a="http://schemas.openxmlformats.org/drawingml/2006/main" id="8" idx="1"/>
@@ -8958,7 +8105,7 @@
       </p:cxnSp>
       <p:cxnSp>
         <p:nvCxnSpPr>
-          <p:cNvPr id="33" name=""/>
+          <p:cNvPr id="63" name=""/>
           <p:cNvCxnSpPr>
             <a:stCxn xmlns:a="http://schemas.openxmlformats.org/drawingml/2006/main" id="8" idx="3"/>
             <a:endCxn xmlns:a="http://schemas.openxmlformats.org/drawingml/2006/main" id="9" idx="1"/>
@@ -8984,7 +8131,7 @@
       </p:cxnSp>
       <p:cxnSp>
         <p:nvCxnSpPr>
-          <p:cNvPr id="34" name=""/>
+          <p:cNvPr id="64" name=""/>
           <p:cNvCxnSpPr>
             <a:stCxn xmlns:a="http://schemas.openxmlformats.org/drawingml/2006/main" id="9" idx="3"/>
             <a:endCxn xmlns:a="http://schemas.openxmlformats.org/drawingml/2006/main" id="10" idx="1"/>
@@ -9041,6 +8188,7 @@
           <a:lstStyle xmlns:a="http://schemas.openxmlformats.org/drawingml/2006/main"/>
           <a:p xmlns:a="http://schemas.openxmlformats.org/drawingml/2006/main">
             <a:pPr algn="l">
+              <a:buNone/>
               <a:defRPr sz="2250" b="1">
                 <a:solidFill>
                   <a:srgbClr val="1F4E79"/>
@@ -9091,6 +8239,7 @@
           <a:lstStyle xmlns:a="http://schemas.openxmlformats.org/drawingml/2006/main"/>
           <a:p xmlns:a="http://schemas.openxmlformats.org/drawingml/2006/main">
             <a:pPr algn="l">
+              <a:buNone/>
               <a:defRPr sz="1575" b="0">
                 <a:solidFill>
                   <a:srgbClr val="111111"/>
@@ -9108,6 +8257,7 @@
           </a:p>
           <a:p xmlns:a="http://schemas.openxmlformats.org/drawingml/2006/main">
             <a:pPr algn="l">
+              <a:buNone/>
               <a:defRPr sz="1575" b="0">
                 <a:solidFill>
                   <a:srgbClr val="111111"/>
@@ -9125,6 +8275,7 @@
           </a:p>
           <a:p xmlns:a="http://schemas.openxmlformats.org/drawingml/2006/main">
             <a:pPr algn="l">
+              <a:buNone/>
               <a:defRPr sz="1575" b="0">
                 <a:solidFill>
                   <a:srgbClr val="111111"/>
@@ -9175,6 +8326,7 @@
           <a:lstStyle xmlns:a="http://schemas.openxmlformats.org/drawingml/2006/main"/>
           <a:p xmlns:a="http://schemas.openxmlformats.org/drawingml/2006/main">
             <a:pPr algn="l">
+              <a:buNone/>
               <a:defRPr sz="2250" b="1">
                 <a:solidFill>
                   <a:srgbClr val="1F4E79"/>
@@ -9225,6 +8377,7 @@
           <a:lstStyle xmlns:a="http://schemas.openxmlformats.org/drawingml/2006/main"/>
           <a:p xmlns:a="http://schemas.openxmlformats.org/drawingml/2006/main">
             <a:pPr algn="l">
+              <a:buNone/>
               <a:defRPr sz="1575" b="0">
                 <a:solidFill>
                   <a:srgbClr val="111111"/>
@@ -9242,6 +8395,7 @@
           </a:p>
           <a:p xmlns:a="http://schemas.openxmlformats.org/drawingml/2006/main">
             <a:pPr algn="l">
+              <a:buNone/>
               <a:defRPr sz="1575" b="0">
                 <a:solidFill>
                   <a:srgbClr val="111111"/>
@@ -9259,6 +8413,7 @@
           </a:p>
           <a:p xmlns:a="http://schemas.openxmlformats.org/drawingml/2006/main">
             <a:pPr algn="l">
+              <a:buNone/>
               <a:defRPr sz="1575" b="0">
                 <a:solidFill>
                   <a:srgbClr val="111111"/>
@@ -9331,6 +8486,7 @@
           <a:lstStyle xmlns:a="http://schemas.openxmlformats.org/drawingml/2006/main"/>
           <a:p xmlns:a="http://schemas.openxmlformats.org/drawingml/2006/main">
             <a:pPr algn="l">
+              <a:buNone/>
               <a:defRPr sz="1050" b="1">
                 <a:solidFill>
                   <a:srgbClr val="1F4E79"/>
@@ -9381,6 +8537,7 @@
           <a:lstStyle xmlns:a="http://schemas.openxmlformats.org/drawingml/2006/main"/>
           <a:p xmlns:a="http://schemas.openxmlformats.org/drawingml/2006/main">
             <a:pPr algn="l">
+              <a:buNone/>
               <a:defRPr sz="2850" b="1">
                 <a:solidFill>
                   <a:srgbClr val="111111"/>
@@ -9431,6 +8588,7 @@
           <a:lstStyle xmlns:a="http://schemas.openxmlformats.org/drawingml/2006/main"/>
           <a:p xmlns:a="http://schemas.openxmlformats.org/drawingml/2006/main">
             <a:pPr algn="r">
+              <a:buNone/>
               <a:defRPr sz="1050" b="0">
                 <a:solidFill>
                   <a:srgbClr val="5F6368"/>
@@ -9512,6 +8670,7 @@
           <a:lstStyle xmlns:a="http://schemas.openxmlformats.org/drawingml/2006/main"/>
           <a:p xmlns:a="http://schemas.openxmlformats.org/drawingml/2006/main">
             <a:pPr algn="l">
+              <a:buNone/>
               <a:defRPr sz="1875" b="1">
                 <a:solidFill>
                   <a:srgbClr val="111111"/>
@@ -9568,6 +8727,7 @@
           <a:lstStyle xmlns:a="http://schemas.openxmlformats.org/drawingml/2006/main"/>
           <a:p xmlns:a="http://schemas.openxmlformats.org/drawingml/2006/main">
             <a:pPr algn="ctr">
+              <a:buNone/>
               <a:defRPr sz="1350" b="1">
                 <a:solidFill>
                   <a:srgbClr val="111111"/>
@@ -9585,6 +8745,7 @@
           </a:p>
           <a:p xmlns:a="http://schemas.openxmlformats.org/drawingml/2006/main">
             <a:pPr algn="ctr">
+              <a:buNone/>
               <a:defRPr sz="1350" b="1">
                 <a:solidFill>
                   <a:srgbClr val="111111"/>
@@ -9641,6 +8802,7 @@
           <a:lstStyle xmlns:a="http://schemas.openxmlformats.org/drawingml/2006/main"/>
           <a:p xmlns:a="http://schemas.openxmlformats.org/drawingml/2006/main">
             <a:pPr algn="ctr">
+              <a:buNone/>
               <a:defRPr sz="1350" b="1">
                 <a:solidFill>
                   <a:srgbClr val="111111"/>
@@ -9658,6 +8820,7 @@
           </a:p>
           <a:p xmlns:a="http://schemas.openxmlformats.org/drawingml/2006/main">
             <a:pPr algn="ctr">
+              <a:buNone/>
               <a:defRPr sz="1350" b="1">
                 <a:solidFill>
                   <a:srgbClr val="111111"/>
@@ -9714,6 +8877,7 @@
           <a:lstStyle xmlns:a="http://schemas.openxmlformats.org/drawingml/2006/main"/>
           <a:p xmlns:a="http://schemas.openxmlformats.org/drawingml/2006/main">
             <a:pPr algn="ctr">
+              <a:buNone/>
               <a:defRPr sz="1650" b="1">
                 <a:solidFill>
                   <a:srgbClr val="111111"/>
@@ -9731,6 +8895,7 @@
           </a:p>
           <a:p xmlns:a="http://schemas.openxmlformats.org/drawingml/2006/main">
             <a:pPr algn="ctr">
+              <a:buNone/>
               <a:defRPr sz="1650" b="1">
                 <a:solidFill>
                   <a:srgbClr val="111111"/>
@@ -9750,7 +8915,7 @@
       </p:sp>
       <p:cxnSp>
         <p:nvCxnSpPr>
-          <p:cNvPr id="27" name=""/>
+          <p:cNvPr id="61" name=""/>
           <p:cNvCxnSpPr>
             <a:stCxn xmlns:a="http://schemas.openxmlformats.org/drawingml/2006/main" id="6" idx="3"/>
             <a:endCxn xmlns:a="http://schemas.openxmlformats.org/drawingml/2006/main" id="8" idx="1"/>
@@ -9776,7 +8941,7 @@
       </p:cxnSp>
       <p:cxnSp>
         <p:nvCxnSpPr>
-          <p:cNvPr id="28" name=""/>
+          <p:cNvPr id="62" name=""/>
           <p:cNvCxnSpPr>
             <a:stCxn xmlns:a="http://schemas.openxmlformats.org/drawingml/2006/main" id="7" idx="3"/>
             <a:endCxn xmlns:a="http://schemas.openxmlformats.org/drawingml/2006/main" id="8" idx="1"/>
@@ -9833,6 +8998,7 @@
           <a:lstStyle xmlns:a="http://schemas.openxmlformats.org/drawingml/2006/main"/>
           <a:p xmlns:a="http://schemas.openxmlformats.org/drawingml/2006/main">
             <a:pPr algn="l">
+              <a:buNone/>
               <a:defRPr sz="1875" b="1">
                 <a:solidFill>
                   <a:srgbClr val="111111"/>
@@ -9889,6 +9055,7 @@
           <a:lstStyle xmlns:a="http://schemas.openxmlformats.org/drawingml/2006/main"/>
           <a:p xmlns:a="http://schemas.openxmlformats.org/drawingml/2006/main">
             <a:pPr algn="ctr">
+              <a:buNone/>
               <a:defRPr sz="1350" b="1">
                 <a:solidFill>
                   <a:srgbClr val="111111"/>
@@ -9906,6 +9073,7 @@
           </a:p>
           <a:p xmlns:a="http://schemas.openxmlformats.org/drawingml/2006/main">
             <a:pPr algn="ctr">
+              <a:buNone/>
               <a:defRPr sz="1350" b="1">
                 <a:solidFill>
                   <a:srgbClr val="111111"/>
@@ -9962,6 +9130,7 @@
           <a:lstStyle xmlns:a="http://schemas.openxmlformats.org/drawingml/2006/main"/>
           <a:p xmlns:a="http://schemas.openxmlformats.org/drawingml/2006/main">
             <a:pPr algn="ctr">
+              <a:buNone/>
               <a:defRPr sz="1350" b="1">
                 <a:solidFill>
                   <a:srgbClr val="111111"/>
@@ -9979,6 +9148,7 @@
           </a:p>
           <a:p xmlns:a="http://schemas.openxmlformats.org/drawingml/2006/main">
             <a:pPr algn="ctr">
+              <a:buNone/>
               <a:defRPr sz="1350" b="1">
                 <a:solidFill>
                   <a:srgbClr val="111111"/>
@@ -10035,6 +9205,7 @@
           <a:lstStyle xmlns:a="http://schemas.openxmlformats.org/drawingml/2006/main"/>
           <a:p xmlns:a="http://schemas.openxmlformats.org/drawingml/2006/main">
             <a:pPr algn="ctr">
+              <a:buNone/>
               <a:defRPr sz="1350" b="1">
                 <a:solidFill>
                   <a:srgbClr val="111111"/>
@@ -10052,6 +9223,7 @@
           </a:p>
           <a:p xmlns:a="http://schemas.openxmlformats.org/drawingml/2006/main">
             <a:pPr algn="ctr">
+              <a:buNone/>
               <a:defRPr sz="1350" b="1">
                 <a:solidFill>
                   <a:srgbClr val="111111"/>
@@ -10108,6 +9280,7 @@
           <a:lstStyle xmlns:a="http://schemas.openxmlformats.org/drawingml/2006/main"/>
           <a:p xmlns:a="http://schemas.openxmlformats.org/drawingml/2006/main">
             <a:pPr algn="ctr">
+              <a:buNone/>
               <a:defRPr sz="1350" b="1">
                 <a:solidFill>
                   <a:srgbClr val="111111"/>
@@ -10125,6 +9298,7 @@
           </a:p>
           <a:p xmlns:a="http://schemas.openxmlformats.org/drawingml/2006/main">
             <a:pPr algn="ctr">
+              <a:buNone/>
               <a:defRPr sz="1350" b="1">
                 <a:solidFill>
                   <a:srgbClr val="111111"/>
@@ -10144,7 +9318,7 @@
       </p:sp>
       <p:cxnSp>
         <p:nvCxnSpPr>
-          <p:cNvPr id="34" name=""/>
+          <p:cNvPr id="68" name=""/>
           <p:cNvCxnSpPr>
             <a:stCxn xmlns:a="http://schemas.openxmlformats.org/drawingml/2006/main" id="12" idx="3"/>
             <a:endCxn xmlns:a="http://schemas.openxmlformats.org/drawingml/2006/main" id="14" idx="1"/>
@@ -10170,7 +9344,7 @@
       </p:cxnSp>
       <p:cxnSp>
         <p:nvCxnSpPr>
-          <p:cNvPr id="35" name=""/>
+          <p:cNvPr id="69" name=""/>
           <p:cNvCxnSpPr>
             <a:stCxn xmlns:a="http://schemas.openxmlformats.org/drawingml/2006/main" id="13" idx="3"/>
             <a:endCxn xmlns:a="http://schemas.openxmlformats.org/drawingml/2006/main" id="15" idx="1"/>
@@ -10227,6 +9401,7 @@
           <a:lstStyle xmlns:a="http://schemas.openxmlformats.org/drawingml/2006/main"/>
           <a:p xmlns:a="http://schemas.openxmlformats.org/drawingml/2006/main">
             <a:pPr algn="ctr">
+              <a:buNone/>
               <a:defRPr sz="1650" b="1">
                 <a:solidFill>
                   <a:srgbClr val="1F4E79"/>
@@ -10299,6 +9474,7 @@
           <a:lstStyle xmlns:a="http://schemas.openxmlformats.org/drawingml/2006/main"/>
           <a:p xmlns:a="http://schemas.openxmlformats.org/drawingml/2006/main">
             <a:pPr algn="l">
+              <a:buNone/>
               <a:defRPr sz="1050" b="1">
                 <a:solidFill>
                   <a:srgbClr val="1F4E79"/>
@@ -10349,6 +9525,7 @@
           <a:lstStyle xmlns:a="http://schemas.openxmlformats.org/drawingml/2006/main"/>
           <a:p xmlns:a="http://schemas.openxmlformats.org/drawingml/2006/main">
             <a:pPr algn="l">
+              <a:buNone/>
               <a:defRPr sz="2850" b="1">
                 <a:solidFill>
                   <a:srgbClr val="111111"/>
@@ -10399,6 +9576,7 @@
           <a:lstStyle xmlns:a="http://schemas.openxmlformats.org/drawingml/2006/main"/>
           <a:p xmlns:a="http://schemas.openxmlformats.org/drawingml/2006/main">
             <a:pPr algn="r">
+              <a:buNone/>
               <a:defRPr sz="1050" b="0">
                 <a:solidFill>
                   <a:srgbClr val="5F6368"/>
@@ -10486,6 +9664,7 @@
           <a:lstStyle xmlns:a="http://schemas.openxmlformats.org/drawingml/2006/main"/>
           <a:p xmlns:a="http://schemas.openxmlformats.org/drawingml/2006/main">
             <a:pPr algn="ctr">
+              <a:buNone/>
               <a:defRPr sz="1350" b="1">
                 <a:solidFill>
                   <a:srgbClr val="111111"/>
@@ -10503,6 +9682,7 @@
           </a:p>
           <a:p xmlns:a="http://schemas.openxmlformats.org/drawingml/2006/main">
             <a:pPr algn="ctr">
+              <a:buNone/>
               <a:defRPr sz="1350" b="1">
                 <a:solidFill>
                   <a:srgbClr val="111111"/>
@@ -10559,6 +9739,7 @@
           <a:lstStyle xmlns:a="http://schemas.openxmlformats.org/drawingml/2006/main"/>
           <a:p xmlns:a="http://schemas.openxmlformats.org/drawingml/2006/main">
             <a:pPr algn="ctr">
+              <a:buNone/>
               <a:defRPr sz="1350" b="1">
                 <a:solidFill>
                   <a:srgbClr val="111111"/>
@@ -10576,6 +9757,7 @@
           </a:p>
           <a:p xmlns:a="http://schemas.openxmlformats.org/drawingml/2006/main">
             <a:pPr algn="ctr">
+              <a:buNone/>
               <a:defRPr sz="1350" b="1">
                 <a:solidFill>
                   <a:srgbClr val="111111"/>
@@ -10632,6 +9814,7 @@
           <a:lstStyle xmlns:a="http://schemas.openxmlformats.org/drawingml/2006/main"/>
           <a:p xmlns:a="http://schemas.openxmlformats.org/drawingml/2006/main">
             <a:pPr algn="ctr">
+              <a:buNone/>
               <a:defRPr sz="1350" b="1">
                 <a:solidFill>
                   <a:srgbClr val="111111"/>
@@ -10649,6 +9832,7 @@
           </a:p>
           <a:p xmlns:a="http://schemas.openxmlformats.org/drawingml/2006/main">
             <a:pPr algn="ctr">
+              <a:buNone/>
               <a:defRPr sz="1350" b="1">
                 <a:solidFill>
                   <a:srgbClr val="111111"/>
@@ -10705,6 +9889,7 @@
           <a:lstStyle xmlns:a="http://schemas.openxmlformats.org/drawingml/2006/main"/>
           <a:p xmlns:a="http://schemas.openxmlformats.org/drawingml/2006/main">
             <a:pPr algn="ctr">
+              <a:buNone/>
               <a:defRPr sz="1350" b="1">
                 <a:solidFill>
                   <a:srgbClr val="111111"/>
@@ -10722,6 +9907,7 @@
           </a:p>
           <a:p xmlns:a="http://schemas.openxmlformats.org/drawingml/2006/main">
             <a:pPr algn="ctr">
+              <a:buNone/>
               <a:defRPr sz="1350" b="1">
                 <a:solidFill>
                   <a:srgbClr val="111111"/>
@@ -10741,7 +9927,7 @@
       </p:sp>
       <p:cxnSp>
         <p:nvCxnSpPr>
-          <p:cNvPr id="23" name=""/>
+          <p:cNvPr id="45" name=""/>
           <p:cNvCxnSpPr>
             <a:stCxn xmlns:a="http://schemas.openxmlformats.org/drawingml/2006/main" id="5" idx="3"/>
             <a:endCxn xmlns:a="http://schemas.openxmlformats.org/drawingml/2006/main" id="6" idx="1"/>
@@ -10767,7 +9953,7 @@
       </p:cxnSp>
       <p:cxnSp>
         <p:nvCxnSpPr>
-          <p:cNvPr id="24" name=""/>
+          <p:cNvPr id="46" name=""/>
           <p:cNvCxnSpPr>
             <a:stCxn xmlns:a="http://schemas.openxmlformats.org/drawingml/2006/main" id="6" idx="3"/>
             <a:endCxn xmlns:a="http://schemas.openxmlformats.org/drawingml/2006/main" id="7" idx="1"/>
@@ -10793,7 +9979,7 @@
       </p:cxnSp>
       <p:cxnSp>
         <p:nvCxnSpPr>
-          <p:cNvPr id="25" name=""/>
+          <p:cNvPr id="47" name=""/>
           <p:cNvCxnSpPr>
             <a:stCxn xmlns:a="http://schemas.openxmlformats.org/drawingml/2006/main" id="7" idx="3"/>
             <a:endCxn xmlns:a="http://schemas.openxmlformats.org/drawingml/2006/main" id="8" idx="1"/>
@@ -10850,6 +10036,7 @@
           <a:lstStyle xmlns:a="http://schemas.openxmlformats.org/drawingml/2006/main"/>
           <a:p xmlns:a="http://schemas.openxmlformats.org/drawingml/2006/main">
             <a:pPr algn="l">
+              <a:buNone/>
               <a:defRPr sz="1725" b="0">
                 <a:solidFill>
                   <a:srgbClr val="111111"/>
@@ -10867,6 +10054,7 @@
           </a:p>
           <a:p xmlns:a="http://schemas.openxmlformats.org/drawingml/2006/main">
             <a:pPr algn="l">
+              <a:buNone/>
               <a:defRPr sz="1725" b="0">
                 <a:solidFill>
                   <a:srgbClr val="111111"/>
@@ -10884,6 +10072,7 @@
           </a:p>
           <a:p xmlns:a="http://schemas.openxmlformats.org/drawingml/2006/main">
             <a:pPr algn="l">
+              <a:buNone/>
               <a:defRPr sz="1725" b="0">
                 <a:solidFill>
                   <a:srgbClr val="111111"/>
@@ -10934,6 +10123,7 @@
           <a:lstStyle xmlns:a="http://schemas.openxmlformats.org/drawingml/2006/main"/>
           <a:p xmlns:a="http://schemas.openxmlformats.org/drawingml/2006/main">
             <a:pPr algn="l">
+              <a:buNone/>
               <a:defRPr sz="4500" b="1">
                 <a:solidFill>
                   <a:srgbClr val="1F4E79"/>
@@ -10984,6 +10174,7 @@
           <a:lstStyle xmlns:a="http://schemas.openxmlformats.org/drawingml/2006/main"/>
           <a:p xmlns:a="http://schemas.openxmlformats.org/drawingml/2006/main">
             <a:pPr algn="l">
+              <a:buNone/>
               <a:defRPr sz="1500" b="0">
                 <a:solidFill>
                   <a:srgbClr val="5F6368"/>
@@ -11056,6 +10247,7 @@
           <a:lstStyle xmlns:a="http://schemas.openxmlformats.org/drawingml/2006/main"/>
           <a:p xmlns:a="http://schemas.openxmlformats.org/drawingml/2006/main">
             <a:pPr algn="l">
+              <a:buNone/>
               <a:defRPr sz="1050" b="1">
                 <a:solidFill>
                   <a:srgbClr val="1F4E79"/>
@@ -11106,6 +10298,7 @@
           <a:lstStyle xmlns:a="http://schemas.openxmlformats.org/drawingml/2006/main"/>
           <a:p xmlns:a="http://schemas.openxmlformats.org/drawingml/2006/main">
             <a:pPr algn="l">
+              <a:buNone/>
               <a:defRPr sz="2850" b="1">
                 <a:solidFill>
                   <a:srgbClr val="111111"/>
@@ -11156,6 +10349,7 @@
           <a:lstStyle xmlns:a="http://schemas.openxmlformats.org/drawingml/2006/main"/>
           <a:p xmlns:a="http://schemas.openxmlformats.org/drawingml/2006/main">
             <a:pPr algn="r">
+              <a:buNone/>
               <a:defRPr sz="1050" b="0">
                 <a:solidFill>
                   <a:srgbClr val="5F6368"/>
@@ -11237,6 +10431,7 @@
           <a:lstStyle xmlns:a="http://schemas.openxmlformats.org/drawingml/2006/main"/>
           <a:p xmlns:a="http://schemas.openxmlformats.org/drawingml/2006/main">
             <a:pPr algn="l">
+              <a:buNone/>
               <a:defRPr sz="2250" b="1">
                 <a:solidFill>
                   <a:srgbClr val="1F4E79"/>
@@ -11287,6 +10482,7 @@
           <a:lstStyle xmlns:a="http://schemas.openxmlformats.org/drawingml/2006/main"/>
           <a:p xmlns:a="http://schemas.openxmlformats.org/drawingml/2006/main">
             <a:pPr algn="l">
+              <a:buNone/>
               <a:defRPr sz="1650" b="0">
                 <a:solidFill>
                   <a:srgbClr val="111111"/>
@@ -11304,6 +10500,7 @@
           </a:p>
           <a:p xmlns:a="http://schemas.openxmlformats.org/drawingml/2006/main">
             <a:pPr algn="l">
+              <a:buNone/>
               <a:defRPr sz="1650" b="0">
                 <a:solidFill>
                   <a:srgbClr val="111111"/>
@@ -11321,6 +10518,7 @@
           </a:p>
           <a:p xmlns:a="http://schemas.openxmlformats.org/drawingml/2006/main">
             <a:pPr algn="l">
+              <a:buNone/>
               <a:defRPr sz="1650" b="0">
                 <a:solidFill>
                   <a:srgbClr val="111111"/>
@@ -11371,6 +10569,7 @@
           <a:lstStyle xmlns:a="http://schemas.openxmlformats.org/drawingml/2006/main"/>
           <a:p xmlns:a="http://schemas.openxmlformats.org/drawingml/2006/main">
             <a:pPr algn="l">
+              <a:buNone/>
               <a:defRPr sz="2250" b="1">
                 <a:solidFill>
                   <a:srgbClr val="1F4E79"/>
@@ -11421,6 +10620,7 @@
           <a:lstStyle xmlns:a="http://schemas.openxmlformats.org/drawingml/2006/main"/>
           <a:p xmlns:a="http://schemas.openxmlformats.org/drawingml/2006/main">
             <a:pPr algn="l">
+              <a:buNone/>
               <a:defRPr sz="1650" b="0">
                 <a:solidFill>
                   <a:srgbClr val="111111"/>
@@ -11438,6 +10638,7 @@
           </a:p>
           <a:p xmlns:a="http://schemas.openxmlformats.org/drawingml/2006/main">
             <a:pPr algn="l">
+              <a:buNone/>
               <a:defRPr sz="1650" b="0">
                 <a:solidFill>
                   <a:srgbClr val="111111"/>
@@ -11455,6 +10656,7 @@
           </a:p>
           <a:p xmlns:a="http://schemas.openxmlformats.org/drawingml/2006/main">
             <a:pPr algn="l">
+              <a:buNone/>
               <a:defRPr sz="1650" b="0">
                 <a:solidFill>
                   <a:srgbClr val="111111"/>
@@ -11538,6 +10740,7 @@
           <a:lstStyle xmlns:a="http://schemas.openxmlformats.org/drawingml/2006/main"/>
           <a:p xmlns:a="http://schemas.openxmlformats.org/drawingml/2006/main">
             <a:pPr algn="ctr">
+              <a:buNone/>
               <a:defRPr sz="1800" b="1">
                 <a:solidFill>
                   <a:srgbClr val="1F4E79"/>
@@ -11610,6 +10813,7 @@
           <a:lstStyle xmlns:a="http://schemas.openxmlformats.org/drawingml/2006/main"/>
           <a:p xmlns:a="http://schemas.openxmlformats.org/drawingml/2006/main">
             <a:pPr algn="l">
+              <a:buNone/>
               <a:defRPr sz="1050" b="1">
                 <a:solidFill>
                   <a:srgbClr val="1F4E79"/>
@@ -11660,6 +10864,7 @@
           <a:lstStyle xmlns:a="http://schemas.openxmlformats.org/drawingml/2006/main"/>
           <a:p xmlns:a="http://schemas.openxmlformats.org/drawingml/2006/main">
             <a:pPr algn="l">
+              <a:buNone/>
               <a:defRPr sz="2850" b="1">
                 <a:solidFill>
                   <a:srgbClr val="111111"/>
@@ -11710,6 +10915,7 @@
           <a:lstStyle xmlns:a="http://schemas.openxmlformats.org/drawingml/2006/main"/>
           <a:p xmlns:a="http://schemas.openxmlformats.org/drawingml/2006/main">
             <a:pPr algn="r">
+              <a:buNone/>
               <a:defRPr sz="1050" b="0">
                 <a:solidFill>
                   <a:srgbClr val="5F6368"/>
@@ -11797,6 +11003,7 @@
           <a:lstStyle xmlns:a="http://schemas.openxmlformats.org/drawingml/2006/main"/>
           <a:p xmlns:a="http://schemas.openxmlformats.org/drawingml/2006/main">
             <a:pPr algn="ctr">
+              <a:buNone/>
               <a:defRPr sz="1650" b="1">
                 <a:solidFill>
                   <a:srgbClr val="111111"/>
@@ -11853,6 +11060,7 @@
           <a:lstStyle xmlns:a="http://schemas.openxmlformats.org/drawingml/2006/main"/>
           <a:p xmlns:a="http://schemas.openxmlformats.org/drawingml/2006/main">
             <a:pPr algn="ctr">
+              <a:buNone/>
               <a:defRPr sz="1350" b="1">
                 <a:solidFill>
                   <a:srgbClr val="111111"/>
@@ -11909,6 +11117,7 @@
           <a:lstStyle xmlns:a="http://schemas.openxmlformats.org/drawingml/2006/main"/>
           <a:p xmlns:a="http://schemas.openxmlformats.org/drawingml/2006/main">
             <a:pPr algn="ctr">
+              <a:buNone/>
               <a:defRPr sz="1350" b="1">
                 <a:solidFill>
                   <a:srgbClr val="111111"/>
@@ -11926,6 +11135,7 @@
           </a:p>
           <a:p xmlns:a="http://schemas.openxmlformats.org/drawingml/2006/main">
             <a:pPr algn="ctr">
+              <a:buNone/>
               <a:defRPr sz="1350" b="1">
                 <a:solidFill>
                   <a:srgbClr val="111111"/>
@@ -11982,6 +11192,7 @@
           <a:lstStyle xmlns:a="http://schemas.openxmlformats.org/drawingml/2006/main"/>
           <a:p xmlns:a="http://schemas.openxmlformats.org/drawingml/2006/main">
             <a:pPr algn="ctr">
+              <a:buNone/>
               <a:defRPr sz="1350" b="1">
                 <a:solidFill>
                   <a:srgbClr val="111111"/>
@@ -12038,6 +11249,7 @@
           <a:lstStyle xmlns:a="http://schemas.openxmlformats.org/drawingml/2006/main"/>
           <a:p xmlns:a="http://schemas.openxmlformats.org/drawingml/2006/main">
             <a:pPr algn="ctr">
+              <a:buNone/>
               <a:defRPr sz="1350" b="1">
                 <a:solidFill>
                   <a:srgbClr val="111111"/>
@@ -12094,6 +11306,7 @@
           <a:lstStyle xmlns:a="http://schemas.openxmlformats.org/drawingml/2006/main"/>
           <a:p xmlns:a="http://schemas.openxmlformats.org/drawingml/2006/main">
             <a:pPr algn="ctr">
+              <a:buNone/>
               <a:defRPr sz="1350" b="1">
                 <a:solidFill>
                   <a:srgbClr val="111111"/>
@@ -12113,7 +11326,7 @@
       </p:sp>
       <p:cxnSp>
         <p:nvCxnSpPr>
-          <p:cNvPr id="29" name=""/>
+          <p:cNvPr id="59" name=""/>
           <p:cNvCxnSpPr>
             <a:stCxn xmlns:a="http://schemas.openxmlformats.org/drawingml/2006/main" id="5" idx="3"/>
             <a:endCxn xmlns:a="http://schemas.openxmlformats.org/drawingml/2006/main" id="6" idx="1"/>
@@ -12139,7 +11352,7 @@
       </p:cxnSp>
       <p:cxnSp>
         <p:nvCxnSpPr>
-          <p:cNvPr id="30" name=""/>
+          <p:cNvPr id="60" name=""/>
           <p:cNvCxnSpPr>
             <a:stCxn xmlns:a="http://schemas.openxmlformats.org/drawingml/2006/main" id="5" idx="3"/>
             <a:endCxn xmlns:a="http://schemas.openxmlformats.org/drawingml/2006/main" id="7" idx="1"/>
@@ -12165,7 +11378,7 @@
       </p:cxnSp>
       <p:cxnSp>
         <p:nvCxnSpPr>
-          <p:cNvPr id="31" name=""/>
+          <p:cNvPr id="61" name=""/>
           <p:cNvCxnSpPr>
             <a:stCxn xmlns:a="http://schemas.openxmlformats.org/drawingml/2006/main" id="5" idx="3"/>
             <a:endCxn xmlns:a="http://schemas.openxmlformats.org/drawingml/2006/main" id="8" idx="1"/>
@@ -12191,7 +11404,7 @@
       </p:cxnSp>
       <p:cxnSp>
         <p:nvCxnSpPr>
-          <p:cNvPr id="32" name=""/>
+          <p:cNvPr id="62" name=""/>
           <p:cNvCxnSpPr>
             <a:stCxn xmlns:a="http://schemas.openxmlformats.org/drawingml/2006/main" id="8" idx="3"/>
             <a:endCxn xmlns:a="http://schemas.openxmlformats.org/drawingml/2006/main" id="9" idx="1"/>
@@ -12217,7 +11430,7 @@
       </p:cxnSp>
       <p:cxnSp>
         <p:nvCxnSpPr>
-          <p:cNvPr id="33" name=""/>
+          <p:cNvPr id="63" name=""/>
           <p:cNvCxnSpPr>
             <a:stCxn xmlns:a="http://schemas.openxmlformats.org/drawingml/2006/main" id="9" idx="3"/>
             <a:endCxn xmlns:a="http://schemas.openxmlformats.org/drawingml/2006/main" id="10" idx="1"/>
@@ -12274,6 +11487,7 @@
           <a:lstStyle xmlns:a="http://schemas.openxmlformats.org/drawingml/2006/main"/>
           <a:p xmlns:a="http://schemas.openxmlformats.org/drawingml/2006/main">
             <a:pPr algn="l">
+              <a:buNone/>
               <a:defRPr sz="2325" b="1">
                 <a:solidFill>
                   <a:srgbClr val="1F4E79"/>
@@ -12324,6 +11538,7 @@
           <a:lstStyle xmlns:a="http://schemas.openxmlformats.org/drawingml/2006/main"/>
           <a:p xmlns:a="http://schemas.openxmlformats.org/drawingml/2006/main">
             <a:pPr algn="l">
+              <a:buNone/>
               <a:defRPr sz="1650" b="0">
                 <a:solidFill>
                   <a:srgbClr val="111111"/>
@@ -12341,6 +11556,7 @@
           </a:p>
           <a:p xmlns:a="http://schemas.openxmlformats.org/drawingml/2006/main">
             <a:pPr algn="l">
+              <a:buNone/>
               <a:defRPr sz="1650" b="0">
                 <a:solidFill>
                   <a:srgbClr val="111111"/>
@@ -12358,6 +11574,7 @@
           </a:p>
           <a:p xmlns:a="http://schemas.openxmlformats.org/drawingml/2006/main">
             <a:pPr algn="l">
+              <a:buNone/>
               <a:defRPr sz="1650" b="0">
                 <a:solidFill>
                   <a:srgbClr val="111111"/>
@@ -12408,6 +11625,7 @@
           <a:lstStyle xmlns:a="http://schemas.openxmlformats.org/drawingml/2006/main"/>
           <a:p xmlns:a="http://schemas.openxmlformats.org/drawingml/2006/main">
             <a:pPr algn="ctr">
+              <a:buNone/>
               <a:defRPr sz="1575" b="1">
                 <a:solidFill>
                   <a:srgbClr val="1F4E79"/>
@@ -12480,6 +11698,7 @@
           <a:lstStyle xmlns:a="http://schemas.openxmlformats.org/drawingml/2006/main"/>
           <a:p xmlns:a="http://schemas.openxmlformats.org/drawingml/2006/main">
             <a:pPr algn="l">
+              <a:buNone/>
               <a:defRPr sz="1050" b="1">
                 <a:solidFill>
                   <a:srgbClr val="1F4E79"/>
@@ -12530,6 +11749,7 @@
           <a:lstStyle xmlns:a="http://schemas.openxmlformats.org/drawingml/2006/main"/>
           <a:p xmlns:a="http://schemas.openxmlformats.org/drawingml/2006/main">
             <a:pPr algn="l">
+              <a:buNone/>
               <a:defRPr sz="2850" b="1">
                 <a:solidFill>
                   <a:srgbClr val="111111"/>
@@ -12580,6 +11800,7 @@
           <a:lstStyle xmlns:a="http://schemas.openxmlformats.org/drawingml/2006/main"/>
           <a:p xmlns:a="http://schemas.openxmlformats.org/drawingml/2006/main">
             <a:pPr algn="r">
+              <a:buNone/>
               <a:defRPr sz="1050" b="0">
                 <a:solidFill>
                   <a:srgbClr val="5F6368"/>
@@ -12661,6 +11882,7 @@
           <a:lstStyle xmlns:a="http://schemas.openxmlformats.org/drawingml/2006/main"/>
           <a:p xmlns:a="http://schemas.openxmlformats.org/drawingml/2006/main">
             <a:pPr algn="l">
+              <a:buNone/>
               <a:defRPr sz="1875" b="1">
                 <a:solidFill>
                   <a:srgbClr val="111111"/>
@@ -12715,6 +11937,7 @@
           <a:lstStyle xmlns:a="http://schemas.openxmlformats.org/drawingml/2006/main"/>
           <a:p xmlns:a="http://schemas.openxmlformats.org/drawingml/2006/main">
             <a:pPr algn="ctr">
+              <a:buNone/>
               <a:defRPr sz="1500" b="1">
                 <a:solidFill>
                   <a:srgbClr val="111111"/>
@@ -12769,6 +11992,7 @@
           <a:lstStyle xmlns:a="http://schemas.openxmlformats.org/drawingml/2006/main"/>
           <a:p xmlns:a="http://schemas.openxmlformats.org/drawingml/2006/main">
             <a:pPr algn="ctr">
+              <a:buNone/>
               <a:defRPr sz="1500" b="1">
                 <a:solidFill>
                   <a:srgbClr val="111111"/>
@@ -12823,6 +12047,7 @@
           <a:lstStyle xmlns:a="http://schemas.openxmlformats.org/drawingml/2006/main"/>
           <a:p xmlns:a="http://schemas.openxmlformats.org/drawingml/2006/main">
             <a:pPr algn="ctr">
+              <a:buNone/>
               <a:defRPr sz="1500" b="1">
                 <a:solidFill>
                   <a:srgbClr val="111111"/>
@@ -12877,6 +12102,7 @@
           <a:lstStyle xmlns:a="http://schemas.openxmlformats.org/drawingml/2006/main"/>
           <a:p xmlns:a="http://schemas.openxmlformats.org/drawingml/2006/main">
             <a:pPr algn="ctr">
+              <a:buNone/>
               <a:defRPr sz="1500" b="1">
                 <a:solidFill>
                   <a:srgbClr val="111111"/>
@@ -12927,6 +12153,7 @@
           <a:lstStyle xmlns:a="http://schemas.openxmlformats.org/drawingml/2006/main"/>
           <a:p xmlns:a="http://schemas.openxmlformats.org/drawingml/2006/main">
             <a:pPr algn="l">
+              <a:buNone/>
               <a:defRPr sz="1875" b="1">
                 <a:solidFill>
                   <a:srgbClr val="1F4E79"/>
@@ -12977,6 +12204,7 @@
           <a:lstStyle xmlns:a="http://schemas.openxmlformats.org/drawingml/2006/main"/>
           <a:p xmlns:a="http://schemas.openxmlformats.org/drawingml/2006/main">
             <a:pPr algn="l">
+              <a:buNone/>
               <a:defRPr sz="1650" b="0">
                 <a:solidFill>
                   <a:srgbClr val="111111"/>
@@ -12994,6 +12222,7 @@
           </a:p>
           <a:p xmlns:a="http://schemas.openxmlformats.org/drawingml/2006/main">
             <a:pPr algn="l">
+              <a:buNone/>
               <a:defRPr sz="1650" b="0">
                 <a:solidFill>
                   <a:srgbClr val="111111"/>
@@ -13011,6 +12240,7 @@
           </a:p>
           <a:p xmlns:a="http://schemas.openxmlformats.org/drawingml/2006/main">
             <a:pPr algn="l">
+              <a:buNone/>
               <a:defRPr sz="1650" b="0">
                 <a:solidFill>
                   <a:srgbClr val="111111"/>
@@ -13028,6 +12258,7 @@
           </a:p>
           <a:p xmlns:a="http://schemas.openxmlformats.org/drawingml/2006/main">
             <a:pPr algn="l">
+              <a:buNone/>
               <a:defRPr sz="1650" b="0">
                 <a:solidFill>
                   <a:srgbClr val="111111"/>
@@ -13111,6 +12342,7 @@
           <a:lstStyle xmlns:a="http://schemas.openxmlformats.org/drawingml/2006/main"/>
           <a:p xmlns:a="http://schemas.openxmlformats.org/drawingml/2006/main">
             <a:pPr algn="ctr">
+              <a:buNone/>
               <a:defRPr sz="1800" b="1">
                 <a:solidFill>
                   <a:srgbClr val="1F4E79"/>
@@ -13128,6 +12360,7 @@
           </a:p>
           <a:p xmlns:a="http://schemas.openxmlformats.org/drawingml/2006/main">
             <a:pPr algn="ctr">
+              <a:buNone/>
               <a:defRPr sz="1800" b="1">
                 <a:solidFill>
                   <a:srgbClr val="1F4E79"/>

</xml_diff>

<commit_message>
docs: polish final submission artifacts
</commit_message>
<xml_diff>
--- a/deliverables/祝宸旭-操作系统课程设计答辩.pptx
+++ b/deliverables/祝宸旭-操作系统课程设计答辩.pptx
@@ -2,26 +2,26 @@
 <file path=ppt/presentation.xml><?xml version="1.0" encoding="utf-8"?>
 <p:presentation xmlns:p="http://schemas.openxmlformats.org/presentationml/2006/main">
   <p:sldMasterIdLst>
-    <p:sldMasterId xmlns:r="http://schemas.openxmlformats.org/officeDocument/2006/relationships" id="2147483648" r:id="R050f89a551a347b4"/>
+    <p:sldMasterId xmlns:r="http://schemas.openxmlformats.org/officeDocument/2006/relationships" id="2147483648" r:id="R8a93ee9f87bf4a94"/>
   </p:sldMasterIdLst>
   <p:notesMasterIdLst>
-    <p:notesMasterId xmlns:r="http://schemas.openxmlformats.org/officeDocument/2006/relationships" r:id="R98916e4ba34044f0"/>
+    <p:notesMasterId xmlns:r="http://schemas.openxmlformats.org/officeDocument/2006/relationships" r:id="Ra80616cb58c4486b"/>
   </p:notesMasterIdLst>
   <p:sldIdLst>
-    <p:sldId xmlns:r="http://schemas.openxmlformats.org/officeDocument/2006/relationships" id="256" r:id="R70474e403e2f44c3"/>
-    <p:sldId xmlns:r="http://schemas.openxmlformats.org/officeDocument/2006/relationships" id="257" r:id="R778a1b488018484f"/>
-    <p:sldId xmlns:r="http://schemas.openxmlformats.org/officeDocument/2006/relationships" id="258" r:id="R8a7bdf3612ca448c"/>
-    <p:sldId xmlns:r="http://schemas.openxmlformats.org/officeDocument/2006/relationships" id="259" r:id="R1f49be82dfb94ee2"/>
-    <p:sldId xmlns:r="http://schemas.openxmlformats.org/officeDocument/2006/relationships" id="260" r:id="R43e648da68dc478f"/>
-    <p:sldId xmlns:r="http://schemas.openxmlformats.org/officeDocument/2006/relationships" id="261" r:id="Rb529ef69347d4fe8"/>
-    <p:sldId xmlns:r="http://schemas.openxmlformats.org/officeDocument/2006/relationships" id="262" r:id="R58e8d04099284b7f"/>
-    <p:sldId xmlns:r="http://schemas.openxmlformats.org/officeDocument/2006/relationships" id="263" r:id="Rc9f6ac3103f444c3"/>
-    <p:sldId xmlns:r="http://schemas.openxmlformats.org/officeDocument/2006/relationships" id="264" r:id="Re5985f8b5269456a"/>
-    <p:sldId xmlns:r="http://schemas.openxmlformats.org/officeDocument/2006/relationships" id="265" r:id="R5a841a9f12c44302"/>
-    <p:sldId xmlns:r="http://schemas.openxmlformats.org/officeDocument/2006/relationships" id="266" r:id="R4b673e7bcc8140bc"/>
-    <p:sldId xmlns:r="http://schemas.openxmlformats.org/officeDocument/2006/relationships" id="267" r:id="Rb0fd687b560c49ed"/>
-    <p:sldId xmlns:r="http://schemas.openxmlformats.org/officeDocument/2006/relationships" id="268" r:id="Rb813abc26fd14fe0"/>
-    <p:sldId xmlns:r="http://schemas.openxmlformats.org/officeDocument/2006/relationships" id="269" r:id="R05992ec6884b48bd"/>
+    <p:sldId xmlns:r="http://schemas.openxmlformats.org/officeDocument/2006/relationships" id="256" r:id="R0f59205653fa476d"/>
+    <p:sldId xmlns:r="http://schemas.openxmlformats.org/officeDocument/2006/relationships" id="257" r:id="R890101e792404702"/>
+    <p:sldId xmlns:r="http://schemas.openxmlformats.org/officeDocument/2006/relationships" id="258" r:id="R68048cc0e5ba4445"/>
+    <p:sldId xmlns:r="http://schemas.openxmlformats.org/officeDocument/2006/relationships" id="259" r:id="Rfdca9beb66b048a6"/>
+    <p:sldId xmlns:r="http://schemas.openxmlformats.org/officeDocument/2006/relationships" id="260" r:id="R3d0b2bbcf9ba4170"/>
+    <p:sldId xmlns:r="http://schemas.openxmlformats.org/officeDocument/2006/relationships" id="261" r:id="Re7cd50cdbb214499"/>
+    <p:sldId xmlns:r="http://schemas.openxmlformats.org/officeDocument/2006/relationships" id="262" r:id="R962ca9ed54d9467c"/>
+    <p:sldId xmlns:r="http://schemas.openxmlformats.org/officeDocument/2006/relationships" id="263" r:id="Rec115587176d4716"/>
+    <p:sldId xmlns:r="http://schemas.openxmlformats.org/officeDocument/2006/relationships" id="264" r:id="Reb93d009d1c94194"/>
+    <p:sldId xmlns:r="http://schemas.openxmlformats.org/officeDocument/2006/relationships" id="265" r:id="Rf622c77860144f7c"/>
+    <p:sldId xmlns:r="http://schemas.openxmlformats.org/officeDocument/2006/relationships" id="266" r:id="R59a7afba8fbf46b4"/>
+    <p:sldId xmlns:r="http://schemas.openxmlformats.org/officeDocument/2006/relationships" id="267" r:id="Rc2f366942b6a454e"/>
+    <p:sldId xmlns:r="http://schemas.openxmlformats.org/officeDocument/2006/relationships" id="268" r:id="R3a09ab22728f4e25"/>
+    <p:sldId xmlns:r="http://schemas.openxmlformats.org/officeDocument/2006/relationships" id="269" r:id="R4db1998b8f8b45ce"/>
   </p:sldIdLst>
   <p:sldSz cx="12192000" cy="6858000"/>
   <p:notesSz cx="6858000" cy="9144000"/>
@@ -1678,7 +1678,7 @@
   </p:cSld>
   <p:clrMap bg1="lt1" tx1="dk1" bg2="lt2" tx2="dk2" accent1="accent1" accent2="accent2" accent3="accent3" accent4="accent4" accent5="accent5" accent6="accent6" hlink="hlink" folHlink="folHlink"/>
   <p:sldLayoutIdLst>
-    <p:sldLayoutId xmlns:r="http://schemas.openxmlformats.org/officeDocument/2006/relationships" id="2147483649" r:id="R6079befbe1b5403f"/>
+    <p:sldLayoutId xmlns:r="http://schemas.openxmlformats.org/officeDocument/2006/relationships" id="2147483649" r:id="R01e61eecfd5d490e"/>
   </p:sldLayoutIdLst>
   <p:txStyles>
     <p:titleStyle>
@@ -3368,7 +3368,7 @@
       </p:sp>
       <p:cxnSp>
         <p:nvCxnSpPr>
-          <p:cNvPr id="60" name=""/>
+          <p:cNvPr id="90" name=""/>
           <p:cNvCxnSpPr>
             <a:stCxn xmlns:a="http://schemas.openxmlformats.org/drawingml/2006/main" id="5" idx="3"/>
             <a:endCxn xmlns:a="http://schemas.openxmlformats.org/drawingml/2006/main" id="6" idx="1"/>
@@ -3394,7 +3394,7 @@
       </p:cxnSp>
       <p:cxnSp>
         <p:nvCxnSpPr>
-          <p:cNvPr id="61" name=""/>
+          <p:cNvPr id="91" name=""/>
           <p:cNvCxnSpPr>
             <a:stCxn xmlns:a="http://schemas.openxmlformats.org/drawingml/2006/main" id="6" idx="3"/>
             <a:endCxn xmlns:a="http://schemas.openxmlformats.org/drawingml/2006/main" id="7" idx="1"/>
@@ -3420,7 +3420,7 @@
       </p:cxnSp>
       <p:cxnSp>
         <p:nvCxnSpPr>
-          <p:cNvPr id="62" name=""/>
+          <p:cNvPr id="92" name=""/>
           <p:cNvCxnSpPr>
             <a:stCxn xmlns:a="http://schemas.openxmlformats.org/drawingml/2006/main" id="7" idx="3"/>
             <a:endCxn xmlns:a="http://schemas.openxmlformats.org/drawingml/2006/main" id="8" idx="1"/>
@@ -3446,7 +3446,7 @@
       </p:cxnSp>
       <p:cxnSp>
         <p:nvCxnSpPr>
-          <p:cNvPr id="63" name=""/>
+          <p:cNvPr id="93" name=""/>
           <p:cNvCxnSpPr>
             <a:stCxn xmlns:a="http://schemas.openxmlformats.org/drawingml/2006/main" id="8" idx="3"/>
             <a:endCxn xmlns:a="http://schemas.openxmlformats.org/drawingml/2006/main" id="9" idx="1"/>
@@ -3472,7 +3472,7 @@
       </p:cxnSp>
       <p:cxnSp>
         <p:nvCxnSpPr>
-          <p:cNvPr id="64" name=""/>
+          <p:cNvPr id="94" name=""/>
           <p:cNvCxnSpPr>
             <a:stCxn xmlns:a="http://schemas.openxmlformats.org/drawingml/2006/main" id="9" idx="3"/>
             <a:endCxn xmlns:a="http://schemas.openxmlformats.org/drawingml/2006/main" id="10" idx="1"/>
@@ -4188,13 +4188,16 @@
           <p:nvPr/>
         </p:nvPicPr>
         <p:blipFill>
-          <a:blip xmlns:r="http://schemas.openxmlformats.org/officeDocument/2006/relationships" xmlns:a="http://schemas.openxmlformats.org/drawingml/2006/main" r:embed="R5cfb3385a4134b6f"/>
-          <a:stretch xmlns:a="http://schemas.openxmlformats.org/drawingml/2006/main"/>
+          <a:blip xmlns:r="http://schemas.openxmlformats.org/officeDocument/2006/relationships" xmlns:a="http://schemas.openxmlformats.org/drawingml/2006/main" r:embed="R37c0c00dc2094a89"/>
+          <a:srcRect xmlns:a="http://schemas.openxmlformats.org/drawingml/2006/main" l="0" t="10638" r="0" b="10638"/>
+          <a:stretch xmlns:a="http://schemas.openxmlformats.org/drawingml/2006/main">
+            <a:fillRect l="0" t="0" r="0" b="0"/>
+          </a:stretch>
         </p:blipFill>
         <p:spPr>
           <a:xfrm xmlns:a="http://schemas.openxmlformats.org/drawingml/2006/main">
-            <a:off x="7207956" y="1752600"/>
-            <a:ext cx="3567289" cy="3009900"/>
+            <a:off x="6286500" y="1752600"/>
+            <a:ext cx="5219700" cy="3467100"/>
           </a:xfrm>
           <a:prstGeom xmlns:a="http://schemas.openxmlformats.org/drawingml/2006/main" prst="rect">
             <a:avLst/>
@@ -4691,7 +4694,7 @@
       </p:sp>
       <p:cxnSp>
         <p:nvCxnSpPr>
-          <p:cNvPr id="47" name=""/>
+          <p:cNvPr id="71" name=""/>
           <p:cNvCxnSpPr>
             <a:stCxn xmlns:a="http://schemas.openxmlformats.org/drawingml/2006/main" id="5" idx="3"/>
             <a:endCxn xmlns:a="http://schemas.openxmlformats.org/drawingml/2006/main" id="6" idx="1"/>
@@ -4717,7 +4720,7 @@
       </p:cxnSp>
       <p:cxnSp>
         <p:nvCxnSpPr>
-          <p:cNvPr id="48" name=""/>
+          <p:cNvPr id="72" name=""/>
           <p:cNvCxnSpPr>
             <a:stCxn xmlns:a="http://schemas.openxmlformats.org/drawingml/2006/main" id="6" idx="3"/>
             <a:endCxn xmlns:a="http://schemas.openxmlformats.org/drawingml/2006/main" id="8" idx="1"/>
@@ -4743,7 +4746,7 @@
       </p:cxnSp>
       <p:cxnSp>
         <p:nvCxnSpPr>
-          <p:cNvPr id="49" name=""/>
+          <p:cNvPr id="73" name=""/>
           <p:cNvCxnSpPr>
             <a:stCxn xmlns:a="http://schemas.openxmlformats.org/drawingml/2006/main" id="8" idx="1"/>
             <a:endCxn xmlns:a="http://schemas.openxmlformats.org/drawingml/2006/main" id="7" idx="3"/>
@@ -4769,7 +4772,7 @@
       </p:cxnSp>
       <p:cxnSp>
         <p:nvCxnSpPr>
-          <p:cNvPr id="50" name=""/>
+          <p:cNvPr id="74" name=""/>
           <p:cNvCxnSpPr>
             <a:stCxn xmlns:a="http://schemas.openxmlformats.org/drawingml/2006/main" id="7" idx="1"/>
             <a:endCxn xmlns:a="http://schemas.openxmlformats.org/drawingml/2006/main" id="5" idx="3"/>
@@ -5164,13 +5167,16 @@
           <p:nvPr/>
         </p:nvPicPr>
         <p:blipFill>
-          <a:blip xmlns:r="http://schemas.openxmlformats.org/officeDocument/2006/relationships" xmlns:a="http://schemas.openxmlformats.org/drawingml/2006/main" r:embed="R194792e07bee4598"/>
-          <a:stretch xmlns:a="http://schemas.openxmlformats.org/drawingml/2006/main"/>
+          <a:blip xmlns:r="http://schemas.openxmlformats.org/officeDocument/2006/relationships" xmlns:a="http://schemas.openxmlformats.org/drawingml/2006/main" r:embed="R0177e275ec5d4e6e"/>
+          <a:srcRect xmlns:a="http://schemas.openxmlformats.org/drawingml/2006/main" l="0" t="20988" r="0" b="20988"/>
+          <a:stretch xmlns:a="http://schemas.openxmlformats.org/drawingml/2006/main">
+            <a:fillRect l="0" t="0" r="0" b="0"/>
+          </a:stretch>
         </p:blipFill>
         <p:spPr>
           <a:xfrm xmlns:a="http://schemas.openxmlformats.org/drawingml/2006/main">
-            <a:off x="3589867" y="1638300"/>
-            <a:ext cx="5012267" cy="4229100"/>
+            <a:off x="1524000" y="1638300"/>
+            <a:ext cx="9144000" cy="4476750"/>
           </a:xfrm>
           <a:prstGeom xmlns:a="http://schemas.openxmlformats.org/drawingml/2006/main" prst="rect">
             <a:avLst/>
@@ -7275,13 +7281,13 @@
           <p:nvPr/>
         </p:nvPicPr>
         <p:blipFill>
-          <a:blip xmlns:r="http://schemas.openxmlformats.org/officeDocument/2006/relationships" xmlns:a="http://schemas.openxmlformats.org/drawingml/2006/main" r:embed="R9b44a8cd6939425f"/>
+          <a:blip xmlns:r="http://schemas.openxmlformats.org/officeDocument/2006/relationships" xmlns:a="http://schemas.openxmlformats.org/drawingml/2006/main" r:embed="R73e5843f9a5749ab"/>
           <a:stretch xmlns:a="http://schemas.openxmlformats.org/drawingml/2006/main"/>
         </p:blipFill>
         <p:spPr>
           <a:xfrm xmlns:a="http://schemas.openxmlformats.org/drawingml/2006/main">
-            <a:off x="685800" y="2628025"/>
-            <a:ext cx="8096250" cy="2230599"/>
+            <a:off x="688975" y="2400300"/>
+            <a:ext cx="8089900" cy="2228850"/>
           </a:xfrm>
           <a:prstGeom xmlns:a="http://schemas.openxmlformats.org/drawingml/2006/main" prst="rect">
             <a:avLst/>
@@ -8027,7 +8033,7 @@
       </p:sp>
       <p:cxnSp>
         <p:nvCxnSpPr>
-          <p:cNvPr id="60" name=""/>
+          <p:cNvPr id="90" name=""/>
           <p:cNvCxnSpPr>
             <a:stCxn xmlns:a="http://schemas.openxmlformats.org/drawingml/2006/main" id="5" idx="3"/>
             <a:endCxn xmlns:a="http://schemas.openxmlformats.org/drawingml/2006/main" id="6" idx="1"/>
@@ -8053,7 +8059,7 @@
       </p:cxnSp>
       <p:cxnSp>
         <p:nvCxnSpPr>
-          <p:cNvPr id="61" name=""/>
+          <p:cNvPr id="91" name=""/>
           <p:cNvCxnSpPr>
             <a:stCxn xmlns:a="http://schemas.openxmlformats.org/drawingml/2006/main" id="6" idx="3"/>
             <a:endCxn xmlns:a="http://schemas.openxmlformats.org/drawingml/2006/main" id="7" idx="1"/>
@@ -8079,7 +8085,7 @@
       </p:cxnSp>
       <p:cxnSp>
         <p:nvCxnSpPr>
-          <p:cNvPr id="62" name=""/>
+          <p:cNvPr id="92" name=""/>
           <p:cNvCxnSpPr>
             <a:stCxn xmlns:a="http://schemas.openxmlformats.org/drawingml/2006/main" id="7" idx="3"/>
             <a:endCxn xmlns:a="http://schemas.openxmlformats.org/drawingml/2006/main" id="8" idx="1"/>
@@ -8105,7 +8111,7 @@
       </p:cxnSp>
       <p:cxnSp>
         <p:nvCxnSpPr>
-          <p:cNvPr id="63" name=""/>
+          <p:cNvPr id="93" name=""/>
           <p:cNvCxnSpPr>
             <a:stCxn xmlns:a="http://schemas.openxmlformats.org/drawingml/2006/main" id="8" idx="3"/>
             <a:endCxn xmlns:a="http://schemas.openxmlformats.org/drawingml/2006/main" id="9" idx="1"/>
@@ -8131,7 +8137,7 @@
       </p:cxnSp>
       <p:cxnSp>
         <p:nvCxnSpPr>
-          <p:cNvPr id="64" name=""/>
+          <p:cNvPr id="94" name=""/>
           <p:cNvCxnSpPr>
             <a:stCxn xmlns:a="http://schemas.openxmlformats.org/drawingml/2006/main" id="9" idx="3"/>
             <a:endCxn xmlns:a="http://schemas.openxmlformats.org/drawingml/2006/main" id="10" idx="1"/>
@@ -8915,7 +8921,7 @@
       </p:sp>
       <p:cxnSp>
         <p:nvCxnSpPr>
-          <p:cNvPr id="61" name=""/>
+          <p:cNvPr id="95" name=""/>
           <p:cNvCxnSpPr>
             <a:stCxn xmlns:a="http://schemas.openxmlformats.org/drawingml/2006/main" id="6" idx="3"/>
             <a:endCxn xmlns:a="http://schemas.openxmlformats.org/drawingml/2006/main" id="8" idx="1"/>
@@ -8941,7 +8947,7 @@
       </p:cxnSp>
       <p:cxnSp>
         <p:nvCxnSpPr>
-          <p:cNvPr id="62" name=""/>
+          <p:cNvPr id="96" name=""/>
           <p:cNvCxnSpPr>
             <a:stCxn xmlns:a="http://schemas.openxmlformats.org/drawingml/2006/main" id="7" idx="3"/>
             <a:endCxn xmlns:a="http://schemas.openxmlformats.org/drawingml/2006/main" id="8" idx="1"/>
@@ -9318,7 +9324,7 @@
       </p:sp>
       <p:cxnSp>
         <p:nvCxnSpPr>
-          <p:cNvPr id="68" name=""/>
+          <p:cNvPr id="102" name=""/>
           <p:cNvCxnSpPr>
             <a:stCxn xmlns:a="http://schemas.openxmlformats.org/drawingml/2006/main" id="12" idx="3"/>
             <a:endCxn xmlns:a="http://schemas.openxmlformats.org/drawingml/2006/main" id="14" idx="1"/>
@@ -9344,7 +9350,7 @@
       </p:cxnSp>
       <p:cxnSp>
         <p:nvCxnSpPr>
-          <p:cNvPr id="69" name=""/>
+          <p:cNvPr id="103" name=""/>
           <p:cNvCxnSpPr>
             <a:stCxn xmlns:a="http://schemas.openxmlformats.org/drawingml/2006/main" id="13" idx="3"/>
             <a:endCxn xmlns:a="http://schemas.openxmlformats.org/drawingml/2006/main" id="15" idx="1"/>
@@ -9927,7 +9933,7 @@
       </p:sp>
       <p:cxnSp>
         <p:nvCxnSpPr>
-          <p:cNvPr id="45" name=""/>
+          <p:cNvPr id="67" name=""/>
           <p:cNvCxnSpPr>
             <a:stCxn xmlns:a="http://schemas.openxmlformats.org/drawingml/2006/main" id="5" idx="3"/>
             <a:endCxn xmlns:a="http://schemas.openxmlformats.org/drawingml/2006/main" id="6" idx="1"/>
@@ -9953,7 +9959,7 @@
       </p:cxnSp>
       <p:cxnSp>
         <p:nvCxnSpPr>
-          <p:cNvPr id="46" name=""/>
+          <p:cNvPr id="68" name=""/>
           <p:cNvCxnSpPr>
             <a:stCxn xmlns:a="http://schemas.openxmlformats.org/drawingml/2006/main" id="6" idx="3"/>
             <a:endCxn xmlns:a="http://schemas.openxmlformats.org/drawingml/2006/main" id="7" idx="1"/>
@@ -9979,7 +9985,7 @@
       </p:cxnSp>
       <p:cxnSp>
         <p:nvCxnSpPr>
-          <p:cNvPr id="47" name=""/>
+          <p:cNvPr id="69" name=""/>
           <p:cNvCxnSpPr>
             <a:stCxn xmlns:a="http://schemas.openxmlformats.org/drawingml/2006/main" id="7" idx="3"/>
             <a:endCxn xmlns:a="http://schemas.openxmlformats.org/drawingml/2006/main" id="8" idx="1"/>
@@ -11326,7 +11332,7 @@
       </p:sp>
       <p:cxnSp>
         <p:nvCxnSpPr>
-          <p:cNvPr id="59" name=""/>
+          <p:cNvPr id="89" name=""/>
           <p:cNvCxnSpPr>
             <a:stCxn xmlns:a="http://schemas.openxmlformats.org/drawingml/2006/main" id="5" idx="3"/>
             <a:endCxn xmlns:a="http://schemas.openxmlformats.org/drawingml/2006/main" id="6" idx="1"/>
@@ -11352,7 +11358,7 @@
       </p:cxnSp>
       <p:cxnSp>
         <p:nvCxnSpPr>
-          <p:cNvPr id="60" name=""/>
+          <p:cNvPr id="90" name=""/>
           <p:cNvCxnSpPr>
             <a:stCxn xmlns:a="http://schemas.openxmlformats.org/drawingml/2006/main" id="5" idx="3"/>
             <a:endCxn xmlns:a="http://schemas.openxmlformats.org/drawingml/2006/main" id="7" idx="1"/>
@@ -11378,7 +11384,7 @@
       </p:cxnSp>
       <p:cxnSp>
         <p:nvCxnSpPr>
-          <p:cNvPr id="61" name=""/>
+          <p:cNvPr id="91" name=""/>
           <p:cNvCxnSpPr>
             <a:stCxn xmlns:a="http://schemas.openxmlformats.org/drawingml/2006/main" id="5" idx="3"/>
             <a:endCxn xmlns:a="http://schemas.openxmlformats.org/drawingml/2006/main" id="8" idx="1"/>
@@ -11404,7 +11410,7 @@
       </p:cxnSp>
       <p:cxnSp>
         <p:nvCxnSpPr>
-          <p:cNvPr id="62" name=""/>
+          <p:cNvPr id="92" name=""/>
           <p:cNvCxnSpPr>
             <a:stCxn xmlns:a="http://schemas.openxmlformats.org/drawingml/2006/main" id="8" idx="3"/>
             <a:endCxn xmlns:a="http://schemas.openxmlformats.org/drawingml/2006/main" id="9" idx="1"/>
@@ -11430,7 +11436,7 @@
       </p:cxnSp>
       <p:cxnSp>
         <p:nvCxnSpPr>
-          <p:cNvPr id="63" name=""/>
+          <p:cNvPr id="93" name=""/>
           <p:cNvCxnSpPr>
             <a:stCxn xmlns:a="http://schemas.openxmlformats.org/drawingml/2006/main" id="9" idx="3"/>
             <a:endCxn xmlns:a="http://schemas.openxmlformats.org/drawingml/2006/main" id="10" idx="1"/>

</xml_diff>

<commit_message>
docs: correct final release artifacts
</commit_message>
<xml_diff>
--- a/deliverables/祝宸旭-操作系统课程设计答辩.pptx
+++ b/deliverables/祝宸旭-操作系统课程设计答辩.pptx
@@ -2,26 +2,26 @@
 <file path=ppt/presentation.xml><?xml version="1.0" encoding="utf-8"?>
 <p:presentation xmlns:p="http://schemas.openxmlformats.org/presentationml/2006/main">
   <p:sldMasterIdLst>
-    <p:sldMasterId xmlns:r="http://schemas.openxmlformats.org/officeDocument/2006/relationships" id="2147483648" r:id="R8a93ee9f87bf4a94"/>
+    <p:sldMasterId xmlns:r="http://schemas.openxmlformats.org/officeDocument/2006/relationships" id="2147483648" r:id="R31ee408602b14749"/>
   </p:sldMasterIdLst>
   <p:notesMasterIdLst>
-    <p:notesMasterId xmlns:r="http://schemas.openxmlformats.org/officeDocument/2006/relationships" r:id="Ra80616cb58c4486b"/>
+    <p:notesMasterId xmlns:r="http://schemas.openxmlformats.org/officeDocument/2006/relationships" r:id="R6e88134e6c624c62"/>
   </p:notesMasterIdLst>
   <p:sldIdLst>
-    <p:sldId xmlns:r="http://schemas.openxmlformats.org/officeDocument/2006/relationships" id="256" r:id="R0f59205653fa476d"/>
-    <p:sldId xmlns:r="http://schemas.openxmlformats.org/officeDocument/2006/relationships" id="257" r:id="R890101e792404702"/>
-    <p:sldId xmlns:r="http://schemas.openxmlformats.org/officeDocument/2006/relationships" id="258" r:id="R68048cc0e5ba4445"/>
-    <p:sldId xmlns:r="http://schemas.openxmlformats.org/officeDocument/2006/relationships" id="259" r:id="Rfdca9beb66b048a6"/>
-    <p:sldId xmlns:r="http://schemas.openxmlformats.org/officeDocument/2006/relationships" id="260" r:id="R3d0b2bbcf9ba4170"/>
-    <p:sldId xmlns:r="http://schemas.openxmlformats.org/officeDocument/2006/relationships" id="261" r:id="Re7cd50cdbb214499"/>
-    <p:sldId xmlns:r="http://schemas.openxmlformats.org/officeDocument/2006/relationships" id="262" r:id="R962ca9ed54d9467c"/>
-    <p:sldId xmlns:r="http://schemas.openxmlformats.org/officeDocument/2006/relationships" id="263" r:id="Rec115587176d4716"/>
-    <p:sldId xmlns:r="http://schemas.openxmlformats.org/officeDocument/2006/relationships" id="264" r:id="Reb93d009d1c94194"/>
-    <p:sldId xmlns:r="http://schemas.openxmlformats.org/officeDocument/2006/relationships" id="265" r:id="Rf622c77860144f7c"/>
-    <p:sldId xmlns:r="http://schemas.openxmlformats.org/officeDocument/2006/relationships" id="266" r:id="R59a7afba8fbf46b4"/>
-    <p:sldId xmlns:r="http://schemas.openxmlformats.org/officeDocument/2006/relationships" id="267" r:id="Rc2f366942b6a454e"/>
-    <p:sldId xmlns:r="http://schemas.openxmlformats.org/officeDocument/2006/relationships" id="268" r:id="R3a09ab22728f4e25"/>
-    <p:sldId xmlns:r="http://schemas.openxmlformats.org/officeDocument/2006/relationships" id="269" r:id="R4db1998b8f8b45ce"/>
+    <p:sldId xmlns:r="http://schemas.openxmlformats.org/officeDocument/2006/relationships" id="256" r:id="R5b2f6e783a7d431d"/>
+    <p:sldId xmlns:r="http://schemas.openxmlformats.org/officeDocument/2006/relationships" id="257" r:id="R4170492dda1d49f4"/>
+    <p:sldId xmlns:r="http://schemas.openxmlformats.org/officeDocument/2006/relationships" id="258" r:id="R1c5ad4bf8a4b4077"/>
+    <p:sldId xmlns:r="http://schemas.openxmlformats.org/officeDocument/2006/relationships" id="259" r:id="Rc267ad991d2643d7"/>
+    <p:sldId xmlns:r="http://schemas.openxmlformats.org/officeDocument/2006/relationships" id="260" r:id="Rffcd40e227b9415b"/>
+    <p:sldId xmlns:r="http://schemas.openxmlformats.org/officeDocument/2006/relationships" id="261" r:id="Rac8c6cc9db7e4846"/>
+    <p:sldId xmlns:r="http://schemas.openxmlformats.org/officeDocument/2006/relationships" id="262" r:id="Rf79420e999614db1"/>
+    <p:sldId xmlns:r="http://schemas.openxmlformats.org/officeDocument/2006/relationships" id="263" r:id="Rebe93d47a3d54b6b"/>
+    <p:sldId xmlns:r="http://schemas.openxmlformats.org/officeDocument/2006/relationships" id="264" r:id="Rfc12e2259ef541b5"/>
+    <p:sldId xmlns:r="http://schemas.openxmlformats.org/officeDocument/2006/relationships" id="265" r:id="R491cbab19d5b476a"/>
+    <p:sldId xmlns:r="http://schemas.openxmlformats.org/officeDocument/2006/relationships" id="266" r:id="R0f834f2e4fb34001"/>
+    <p:sldId xmlns:r="http://schemas.openxmlformats.org/officeDocument/2006/relationships" id="267" r:id="R7ccf756013124ae1"/>
+    <p:sldId xmlns:r="http://schemas.openxmlformats.org/officeDocument/2006/relationships" id="268" r:id="Re6324cf40a7643e9"/>
+    <p:sldId xmlns:r="http://schemas.openxmlformats.org/officeDocument/2006/relationships" id="269" r:id="R330ddab7d5c7426d"/>
   </p:sldIdLst>
   <p:sldSz cx="12192000" cy="6858000"/>
   <p:notesSz cx="6858000" cy="9144000"/>
@@ -1678,7 +1678,7 @@
   </p:cSld>
   <p:clrMap bg1="lt1" tx1="dk1" bg2="lt2" tx2="dk2" accent1="accent1" accent2="accent2" accent3="accent3" accent4="accent4" accent5="accent5" accent6="accent6" hlink="hlink" folHlink="folHlink"/>
   <p:sldLayoutIdLst>
-    <p:sldLayoutId xmlns:r="http://schemas.openxmlformats.org/officeDocument/2006/relationships" id="2147483649" r:id="R01e61eecfd5d490e"/>
+    <p:sldLayoutId xmlns:r="http://schemas.openxmlformats.org/officeDocument/2006/relationships" id="2147483649" r:id="R980cd88298024f60"/>
   </p:sldLayoutIdLst>
   <p:txStyles>
     <p:titleStyle>
@@ -3368,7 +3368,7 @@
       </p:sp>
       <p:cxnSp>
         <p:nvCxnSpPr>
-          <p:cNvPr id="90" name=""/>
+          <p:cNvPr id="120" name=""/>
           <p:cNvCxnSpPr>
             <a:stCxn xmlns:a="http://schemas.openxmlformats.org/drawingml/2006/main" id="5" idx="3"/>
             <a:endCxn xmlns:a="http://schemas.openxmlformats.org/drawingml/2006/main" id="6" idx="1"/>
@@ -3394,7 +3394,7 @@
       </p:cxnSp>
       <p:cxnSp>
         <p:nvCxnSpPr>
-          <p:cNvPr id="91" name=""/>
+          <p:cNvPr id="121" name=""/>
           <p:cNvCxnSpPr>
             <a:stCxn xmlns:a="http://schemas.openxmlformats.org/drawingml/2006/main" id="6" idx="3"/>
             <a:endCxn xmlns:a="http://schemas.openxmlformats.org/drawingml/2006/main" id="7" idx="1"/>
@@ -3420,7 +3420,7 @@
       </p:cxnSp>
       <p:cxnSp>
         <p:nvCxnSpPr>
-          <p:cNvPr id="92" name=""/>
+          <p:cNvPr id="122" name=""/>
           <p:cNvCxnSpPr>
             <a:stCxn xmlns:a="http://schemas.openxmlformats.org/drawingml/2006/main" id="7" idx="3"/>
             <a:endCxn xmlns:a="http://schemas.openxmlformats.org/drawingml/2006/main" id="8" idx="1"/>
@@ -3446,7 +3446,7 @@
       </p:cxnSp>
       <p:cxnSp>
         <p:nvCxnSpPr>
-          <p:cNvPr id="93" name=""/>
+          <p:cNvPr id="123" name=""/>
           <p:cNvCxnSpPr>
             <a:stCxn xmlns:a="http://schemas.openxmlformats.org/drawingml/2006/main" id="8" idx="3"/>
             <a:endCxn xmlns:a="http://schemas.openxmlformats.org/drawingml/2006/main" id="9" idx="1"/>
@@ -3472,7 +3472,7 @@
       </p:cxnSp>
       <p:cxnSp>
         <p:nvCxnSpPr>
-          <p:cNvPr id="94" name=""/>
+          <p:cNvPr id="124" name=""/>
           <p:cNvCxnSpPr>
             <a:stCxn xmlns:a="http://schemas.openxmlformats.org/drawingml/2006/main" id="9" idx="3"/>
             <a:endCxn xmlns:a="http://schemas.openxmlformats.org/drawingml/2006/main" id="10" idx="1"/>
@@ -4188,7 +4188,7 @@
           <p:nvPr/>
         </p:nvPicPr>
         <p:blipFill>
-          <a:blip xmlns:r="http://schemas.openxmlformats.org/officeDocument/2006/relationships" xmlns:a="http://schemas.openxmlformats.org/drawingml/2006/main" r:embed="R37c0c00dc2094a89"/>
+          <a:blip xmlns:r="http://schemas.openxmlformats.org/officeDocument/2006/relationships" xmlns:a="http://schemas.openxmlformats.org/drawingml/2006/main" r:embed="Redf6096ce6274ddb"/>
           <a:srcRect xmlns:a="http://schemas.openxmlformats.org/drawingml/2006/main" l="0" t="10638" r="0" b="10638"/>
           <a:stretch xmlns:a="http://schemas.openxmlformats.org/drawingml/2006/main">
             <a:fillRect l="0" t="0" r="0" b="0"/>
@@ -4694,7 +4694,7 @@
       </p:sp>
       <p:cxnSp>
         <p:nvCxnSpPr>
-          <p:cNvPr id="71" name=""/>
+          <p:cNvPr id="95" name=""/>
           <p:cNvCxnSpPr>
             <a:stCxn xmlns:a="http://schemas.openxmlformats.org/drawingml/2006/main" id="5" idx="3"/>
             <a:endCxn xmlns:a="http://schemas.openxmlformats.org/drawingml/2006/main" id="6" idx="1"/>
@@ -4720,7 +4720,7 @@
       </p:cxnSp>
       <p:cxnSp>
         <p:nvCxnSpPr>
-          <p:cNvPr id="72" name=""/>
+          <p:cNvPr id="96" name=""/>
           <p:cNvCxnSpPr>
             <a:stCxn xmlns:a="http://schemas.openxmlformats.org/drawingml/2006/main" id="6" idx="3"/>
             <a:endCxn xmlns:a="http://schemas.openxmlformats.org/drawingml/2006/main" id="8" idx="1"/>
@@ -4746,7 +4746,7 @@
       </p:cxnSp>
       <p:cxnSp>
         <p:nvCxnSpPr>
-          <p:cNvPr id="73" name=""/>
+          <p:cNvPr id="97" name=""/>
           <p:cNvCxnSpPr>
             <a:stCxn xmlns:a="http://schemas.openxmlformats.org/drawingml/2006/main" id="8" idx="1"/>
             <a:endCxn xmlns:a="http://schemas.openxmlformats.org/drawingml/2006/main" id="7" idx="3"/>
@@ -4772,7 +4772,7 @@
       </p:cxnSp>
       <p:cxnSp>
         <p:nvCxnSpPr>
-          <p:cNvPr id="74" name=""/>
+          <p:cNvPr id="98" name=""/>
           <p:cNvCxnSpPr>
             <a:stCxn xmlns:a="http://schemas.openxmlformats.org/drawingml/2006/main" id="7" idx="1"/>
             <a:endCxn xmlns:a="http://schemas.openxmlformats.org/drawingml/2006/main" id="5" idx="3"/>
@@ -5167,16 +5167,13 @@
           <p:nvPr/>
         </p:nvPicPr>
         <p:blipFill>
-          <a:blip xmlns:r="http://schemas.openxmlformats.org/officeDocument/2006/relationships" xmlns:a="http://schemas.openxmlformats.org/drawingml/2006/main" r:embed="R0177e275ec5d4e6e"/>
-          <a:srcRect xmlns:a="http://schemas.openxmlformats.org/drawingml/2006/main" l="0" t="20988" r="0" b="20988"/>
-          <a:stretch xmlns:a="http://schemas.openxmlformats.org/drawingml/2006/main">
-            <a:fillRect l="0" t="0" r="0" b="0"/>
-          </a:stretch>
+          <a:blip xmlns:r="http://schemas.openxmlformats.org/officeDocument/2006/relationships" xmlns:a="http://schemas.openxmlformats.org/drawingml/2006/main" r:embed="R3b9b5e59a7e24b87"/>
+          <a:stretch xmlns:a="http://schemas.openxmlformats.org/drawingml/2006/main"/>
         </p:blipFill>
         <p:spPr>
           <a:xfrm xmlns:a="http://schemas.openxmlformats.org/drawingml/2006/main">
-            <a:off x="1524000" y="1638300"/>
-            <a:ext cx="9144000" cy="4476750"/>
+            <a:off x="1408654" y="1524000"/>
+            <a:ext cx="9374692" cy="4819650"/>
           </a:xfrm>
           <a:prstGeom xmlns:a="http://schemas.openxmlformats.org/drawingml/2006/main" prst="rect">
             <a:avLst/>
@@ -7281,7 +7278,7 @@
           <p:nvPr/>
         </p:nvPicPr>
         <p:blipFill>
-          <a:blip xmlns:r="http://schemas.openxmlformats.org/officeDocument/2006/relationships" xmlns:a="http://schemas.openxmlformats.org/drawingml/2006/main" r:embed="R73e5843f9a5749ab"/>
+          <a:blip xmlns:r="http://schemas.openxmlformats.org/officeDocument/2006/relationships" xmlns:a="http://schemas.openxmlformats.org/drawingml/2006/main" r:embed="Rc79caa0b6f5745ae"/>
           <a:stretch xmlns:a="http://schemas.openxmlformats.org/drawingml/2006/main"/>
         </p:blipFill>
         <p:spPr>
@@ -8033,7 +8030,7 @@
       </p:sp>
       <p:cxnSp>
         <p:nvCxnSpPr>
-          <p:cNvPr id="90" name=""/>
+          <p:cNvPr id="120" name=""/>
           <p:cNvCxnSpPr>
             <a:stCxn xmlns:a="http://schemas.openxmlformats.org/drawingml/2006/main" id="5" idx="3"/>
             <a:endCxn xmlns:a="http://schemas.openxmlformats.org/drawingml/2006/main" id="6" idx="1"/>
@@ -8059,7 +8056,7 @@
       </p:cxnSp>
       <p:cxnSp>
         <p:nvCxnSpPr>
-          <p:cNvPr id="91" name=""/>
+          <p:cNvPr id="121" name=""/>
           <p:cNvCxnSpPr>
             <a:stCxn xmlns:a="http://schemas.openxmlformats.org/drawingml/2006/main" id="6" idx="3"/>
             <a:endCxn xmlns:a="http://schemas.openxmlformats.org/drawingml/2006/main" id="7" idx="1"/>
@@ -8085,7 +8082,7 @@
       </p:cxnSp>
       <p:cxnSp>
         <p:nvCxnSpPr>
-          <p:cNvPr id="92" name=""/>
+          <p:cNvPr id="122" name=""/>
           <p:cNvCxnSpPr>
             <a:stCxn xmlns:a="http://schemas.openxmlformats.org/drawingml/2006/main" id="7" idx="3"/>
             <a:endCxn xmlns:a="http://schemas.openxmlformats.org/drawingml/2006/main" id="8" idx="1"/>
@@ -8111,7 +8108,7 @@
       </p:cxnSp>
       <p:cxnSp>
         <p:nvCxnSpPr>
-          <p:cNvPr id="93" name=""/>
+          <p:cNvPr id="123" name=""/>
           <p:cNvCxnSpPr>
             <a:stCxn xmlns:a="http://schemas.openxmlformats.org/drawingml/2006/main" id="8" idx="3"/>
             <a:endCxn xmlns:a="http://schemas.openxmlformats.org/drawingml/2006/main" id="9" idx="1"/>
@@ -8137,7 +8134,7 @@
       </p:cxnSp>
       <p:cxnSp>
         <p:nvCxnSpPr>
-          <p:cNvPr id="94" name=""/>
+          <p:cNvPr id="124" name=""/>
           <p:cNvCxnSpPr>
             <a:stCxn xmlns:a="http://schemas.openxmlformats.org/drawingml/2006/main" id="9" idx="3"/>
             <a:endCxn xmlns:a="http://schemas.openxmlformats.org/drawingml/2006/main" id="10" idx="1"/>
@@ -8921,7 +8918,7 @@
       </p:sp>
       <p:cxnSp>
         <p:nvCxnSpPr>
-          <p:cNvPr id="95" name=""/>
+          <p:cNvPr id="129" name=""/>
           <p:cNvCxnSpPr>
             <a:stCxn xmlns:a="http://schemas.openxmlformats.org/drawingml/2006/main" id="6" idx="3"/>
             <a:endCxn xmlns:a="http://schemas.openxmlformats.org/drawingml/2006/main" id="8" idx="1"/>
@@ -8947,7 +8944,7 @@
       </p:cxnSp>
       <p:cxnSp>
         <p:nvCxnSpPr>
-          <p:cNvPr id="96" name=""/>
+          <p:cNvPr id="130" name=""/>
           <p:cNvCxnSpPr>
             <a:stCxn xmlns:a="http://schemas.openxmlformats.org/drawingml/2006/main" id="7" idx="3"/>
             <a:endCxn xmlns:a="http://schemas.openxmlformats.org/drawingml/2006/main" id="8" idx="1"/>
@@ -9324,7 +9321,7 @@
       </p:sp>
       <p:cxnSp>
         <p:nvCxnSpPr>
-          <p:cNvPr id="102" name=""/>
+          <p:cNvPr id="136" name=""/>
           <p:cNvCxnSpPr>
             <a:stCxn xmlns:a="http://schemas.openxmlformats.org/drawingml/2006/main" id="12" idx="3"/>
             <a:endCxn xmlns:a="http://schemas.openxmlformats.org/drawingml/2006/main" id="14" idx="1"/>
@@ -9350,7 +9347,7 @@
       </p:cxnSp>
       <p:cxnSp>
         <p:nvCxnSpPr>
-          <p:cNvPr id="103" name=""/>
+          <p:cNvPr id="137" name=""/>
           <p:cNvCxnSpPr>
             <a:stCxn xmlns:a="http://schemas.openxmlformats.org/drawingml/2006/main" id="13" idx="3"/>
             <a:endCxn xmlns:a="http://schemas.openxmlformats.org/drawingml/2006/main" id="15" idx="1"/>
@@ -9933,7 +9930,7 @@
       </p:sp>
       <p:cxnSp>
         <p:nvCxnSpPr>
-          <p:cNvPr id="67" name=""/>
+          <p:cNvPr id="89" name=""/>
           <p:cNvCxnSpPr>
             <a:stCxn xmlns:a="http://schemas.openxmlformats.org/drawingml/2006/main" id="5" idx="3"/>
             <a:endCxn xmlns:a="http://schemas.openxmlformats.org/drawingml/2006/main" id="6" idx="1"/>
@@ -9959,7 +9956,7 @@
       </p:cxnSp>
       <p:cxnSp>
         <p:nvCxnSpPr>
-          <p:cNvPr id="68" name=""/>
+          <p:cNvPr id="90" name=""/>
           <p:cNvCxnSpPr>
             <a:stCxn xmlns:a="http://schemas.openxmlformats.org/drawingml/2006/main" id="6" idx="3"/>
             <a:endCxn xmlns:a="http://schemas.openxmlformats.org/drawingml/2006/main" id="7" idx="1"/>
@@ -9985,7 +9982,7 @@
       </p:cxnSp>
       <p:cxnSp>
         <p:nvCxnSpPr>
-          <p:cNvPr id="69" name=""/>
+          <p:cNvPr id="91" name=""/>
           <p:cNvCxnSpPr>
             <a:stCxn xmlns:a="http://schemas.openxmlformats.org/drawingml/2006/main" id="7" idx="3"/>
             <a:endCxn xmlns:a="http://schemas.openxmlformats.org/drawingml/2006/main" id="8" idx="1"/>
@@ -11332,7 +11329,7 @@
       </p:sp>
       <p:cxnSp>
         <p:nvCxnSpPr>
-          <p:cNvPr id="89" name=""/>
+          <p:cNvPr id="119" name=""/>
           <p:cNvCxnSpPr>
             <a:stCxn xmlns:a="http://schemas.openxmlformats.org/drawingml/2006/main" id="5" idx="3"/>
             <a:endCxn xmlns:a="http://schemas.openxmlformats.org/drawingml/2006/main" id="6" idx="1"/>
@@ -11358,7 +11355,7 @@
       </p:cxnSp>
       <p:cxnSp>
         <p:nvCxnSpPr>
-          <p:cNvPr id="90" name=""/>
+          <p:cNvPr id="120" name=""/>
           <p:cNvCxnSpPr>
             <a:stCxn xmlns:a="http://schemas.openxmlformats.org/drawingml/2006/main" id="5" idx="3"/>
             <a:endCxn xmlns:a="http://schemas.openxmlformats.org/drawingml/2006/main" id="7" idx="1"/>
@@ -11384,7 +11381,7 @@
       </p:cxnSp>
       <p:cxnSp>
         <p:nvCxnSpPr>
-          <p:cNvPr id="91" name=""/>
+          <p:cNvPr id="121" name=""/>
           <p:cNvCxnSpPr>
             <a:stCxn xmlns:a="http://schemas.openxmlformats.org/drawingml/2006/main" id="5" idx="3"/>
             <a:endCxn xmlns:a="http://schemas.openxmlformats.org/drawingml/2006/main" id="8" idx="1"/>
@@ -11410,7 +11407,7 @@
       </p:cxnSp>
       <p:cxnSp>
         <p:nvCxnSpPr>
-          <p:cNvPr id="92" name=""/>
+          <p:cNvPr id="122" name=""/>
           <p:cNvCxnSpPr>
             <a:stCxn xmlns:a="http://schemas.openxmlformats.org/drawingml/2006/main" id="8" idx="3"/>
             <a:endCxn xmlns:a="http://schemas.openxmlformats.org/drawingml/2006/main" id="9" idx="1"/>
@@ -11436,7 +11433,7 @@
       </p:cxnSp>
       <p:cxnSp>
         <p:nvCxnSpPr>
-          <p:cNvPr id="93" name=""/>
+          <p:cNvPr id="123" name=""/>
           <p:cNvCxnSpPr>
             <a:stCxn xmlns:a="http://schemas.openxmlformats.org/drawingml/2006/main" id="9" idx="3"/>
             <a:endCxn xmlns:a="http://schemas.openxmlformats.org/drawingml/2006/main" id="10" idx="1"/>

</xml_diff>